<commit_message>
S6: anotar en las notas que Sora ya no existe y que el video de AI Studio es de pago
Comprobado en la fuente: OpenAI descontinuo Sora el 26 de abril de 2026 (web y
app). En AI Studio la categoria Video tiene un unico modelo, marcado "Paid".
La app de Gemini con cuenta personal queda como la unica ruta gratuita.

Co-Authored-By: Claude Opus 5 <noreply@anthropic.com>
</commit_message>
<xml_diff>
--- a/_static/sesion06/S06_audio_imagen_video.pptx
+++ b/_static/sesion06/S06_audio_imagen_video.pptx
@@ -1557,6 +1557,28 @@
           <a:p>
             <a:r>
               <a:t>Por eso la Ruta B de la diapositiva 13 no es un adorno: es el plan para medio salón.</a:t>
+            </a:r>
+          </a:p>
+          <a:p/>
+          <a:p>
+            <a:r>
+              <a:t>SI ALGUIEN PREGUNTA POR OTRAS RUTAS, las dos obvias están descartadas y lo comprobé:</a:t>
+            </a:r>
+          </a:p>
+          <a:p>
+            <a:r>
+              <a:t>· SORA (OpenAI) ya no existe. Lo descontinuaron el 26 de abril de 2026, web y app; la API se apaga el 24 de septiembre de 2026. Está en el centro de ayuda de OpenAI.</a:t>
+            </a:r>
+          </a:p>
+          <a:p>
+            <a:r>
+              <a:t>· GOOGLE AI STUDIO sí tiene generación de video, pero es de pago: el único modelo de la categoría Video está marcado "Paid" y cuesta unos 7,50 dólares por salida. El nivel gratuito de AI Studio cubre texto y audio —por eso la voz sí funciona ahí— pero no video.</a:t>
+            </a:r>
+          </a:p>
+          <a:p/>
+          <a:p>
+            <a:r>
+              <a:t>O sea: para video gratis, la app de Gemini con cuenta personal es la única puerta. No hay plan C.</a:t>
             </a:r>
           </a:p>
         </p:txBody>

</xml_diff>

<commit_message>
S6: bajar el entregable a tres clips y corregir por donde se generan
En la app de Gemini, Crear video resulto ser funcion de pago: se comprobo que no
aparece ni en la cuenta institucional ni en una cuenta Gmail gratuita, solo en
la Pro. La puerta gratuita es Google Flow (50 creditos diarios segun la pagina
de precios de Google), pendiente de verificar de punta a punta.

El entregable baja de un minuto a 30 segundos: tres clips de 10 s, 75 palabras.
Seis clips no caben en la sesion porque cada uno tarda de 2 a 4 minutos.

Co-Authored-By: Claude Opus 5 <noreply@anthropic.com>
</commit_message>
<xml_diff>
--- a/_static/sesion06/S06_audio_imagen_video.pptx
+++ b/_static/sesion06/S06_audio_imagen_video.pptx
@@ -529,7 +529,13 @@
           <a:p/>
           <a:p>
             <a:r>
-              <a:t>AVISO QUE HAY QUE DAR DE ENTRADA: esto necesita cuenta de Gmail personal. La institucional de la Universidad no tiene Crear video; lo comprobé en UCaldas y en la UAM. Quien solo tenga la institucional va por la Ruta B, que está en la diapositiva 13 y funciona igual de bien.</a:t>
+              <a:t>AVISO QUE HAY QUE DAR DE ENTRADA: esto necesita cuenta de Google personal; la institucional no sirve para generar video (comprobado en UCaldas y en la UAM).</a:t>
+            </a:r>
+          </a:p>
+          <a:p/>
+          <a:p>
+            <a:r>
+              <a:t>Y OJO CON DÓNDE: en la app de Gemini, Crear video solo aparece con plan de pago. En cuenta gratuita NO está; lo comprobé. La puerta gratuita es Google Flow: 50 créditos diarios según la página de precios de Google. Verifícalo tú antes de la clase. Si no sirve ese día, Ruta B (diapositiva 13).</a:t>
             </a:r>
           </a:p>
         </p:txBody>
@@ -616,7 +622,7 @@
           </a:p>
           <a:p>
             <a:r>
-              <a:t>«Une estos clips en un solo video, en este orden: clip1, clip2, clip3... Conserva el audio de cada uno. Déjame el archivo mp4 para descargar.»</a:t>
+              <a:t>«Une estos clips en un solo video, en este orden: clip1, clip2, clip3. Conserva el audio de cada uno. Déjame el archivo mp4 para descargar.»</a:t>
             </a:r>
           </a:p>
           <a:p/>
@@ -710,7 +716,7 @@
           <a:p/>
           <a:p>
             <a:r>
-              <a:t>Cuándo vale la pena hacerlo aparte: cuando la voz que eligió Veo no les gusta, o cuando quieren que suene igual en los seis clips (Veo puede variarla un poco entre uno y otro).</a:t>
+              <a:t>Cuándo vale la pena hacerlo aparte: cuando la voz que eligió Veo no les gusta, o cuando quieren que suene igual en los tres clips (Veo puede variarla un poco entre uno y otro).</a:t>
             </a:r>
           </a:p>
           <a:p/>
@@ -896,7 +902,7 @@
           <a:lstStyle/>
           <a:p>
             <a:r>
-              <a:t>LA RUTA B. Esta diapositiva no es un adorno: es el plan para quien solo tenga la cuenta institucional o se quede sin cupo. En un salón de treinta, va a ser bastante gente.</a:t>
+              <a:t>LA RUTA B. Esta diapositiva no es un adorno: es el plan para quien solo tenga la cuenta institucional, se quede sin créditos, o para todo el salón si Flow no funciona ese día.</a:t>
             </a:r>
           </a:p>
           <a:p/>
@@ -1016,7 +1022,7 @@
           <a:p/>
           <a:p>
             <a:r>
-              <a:t>EL GUION COMPLETO (150 palabras partidas en seis frases). Las dos primeras, que son las del ejemplo:</a:t>
+              <a:t>EL GUION COMPLETO. El ejemplo que se proyecta son las dos primeras frases; a ellos se les piden tres. Dejo las seis por si quieres mostrar la versión larga:</a:t>
             </a:r>
           </a:p>
           <a:p>
@@ -1064,6 +1070,12 @@
           <a:p>
             <a:r>
               <a:t>MOSTRAR QUE EL PERSONAJE SE MANTIENE: misma cara, misma camisa, mismo salón en los dos clips. Eso lo logra adjuntar la misma foto, nada más.</a:t>
+            </a:r>
+          </a:p>
+          <a:p/>
+          <a:p>
+            <a:r>
+              <a:t>Si quieres las tres frases justas para el encargo de clase, usa la 1, la 2 y la 6: enganchan, explican y cierran con pregunta.</a:t>
             </a:r>
           </a:p>
         </p:txBody>
@@ -1181,7 +1193,12 @@
           </a:p>
           <a:p>
             <a:r>
-              <a:t>· «Es la misma foto en todos» — a quien le salieron seis personas distintas.</a:t>
+              <a:t>· «Es la misma foto en todos» — a quien le salieron tres personas distintas.</a:t>
+            </a:r>
+          </a:p>
+          <a:p>
+            <a:r>
+              <a:t>· «Prueba Flow» — a quien no le aparece Crear video en Gemini.</a:t>
             </a:r>
           </a:p>
           <a:p>
@@ -1279,7 +1296,7 @@
           </a:p>
           <a:p>
             <a:r>
-              <a:t>· ¿Qué parte costó más? (casi siempre: partir el guion en seis, no la tecnología)</a:t>
+              <a:t>· ¿Qué parte costó más? (casi siempre: partir el guion, no la tecnología)</a:t>
             </a:r>
           </a:p>
           <a:p>
@@ -1371,13 +1388,19 @@
           <a:p/>
           <a:p>
             <a:r>
-              <a:t>Reproducir el ejemplo. Preguntar después: ¿cuántos videos distintos creen que hay aquí? La respuesta —seis clips pegados— es la agenda de la clase.</a:t>
+              <a:t>Reproducir el ejemplo. Preguntar después: ¿cuántos videos distintos creen que hay aquí? La respuesta —son clips pegados— es la agenda de la clase.</a:t>
             </a:r>
           </a:p>
           <a:p/>
           <a:p>
             <a:r>
-              <a:t>El punto pedagógico: no se hace un video de un minuto. Se hacen seis de diez segundos y se pegan. Eso es lo que lo vuelve alcanzable.</a:t>
+              <a:t>El punto pedagógico: no se hace un video de corrido. Se hacen pedazos de diez segundos y se pegan. Eso es lo que lo vuelve alcanzable.</a:t>
+            </a:r>
+          </a:p>
+          <a:p/>
+          <a:p>
+            <a:r>
+              <a:t>POR QUÉ TRES Y NO SEIS: cada clip tarda de dos a cuatro minutos en generarse y el cupo gratuito es limitado. Tres clips caben en la sesión y se llevan el video terminado; seis dejan a media clase sin acabar. Quien tenga cupo y ganas, que haga seis.</a:t>
             </a:r>
           </a:p>
         </p:txBody>
@@ -1535,28 +1558,38 @@
           <a:p/>
           <a:p>
             <a:r>
-              <a:t>COMPROBADO al preparar la clase:</a:t>
-            </a:r>
-          </a:p>
-          <a:p>
-            <a:r>
-              <a:t>· La cuenta institucional (UCaldas y UAM) NO tiene Crear video. El menú solo llega hasta Deep Research. Hace falta Gmail personal.</a:t>
-            </a:r>
-          </a:p>
-          <a:p>
-            <a:r>
-              <a:t>· El cupo no lo publica Google. En cuenta Pro son unos 3 videos al día. En gratuita puede ser poco o ninguno ese día.</a:t>
-            </a:r>
-          </a:p>
-          <a:p>
-            <a:r>
-              <a:t>· Gemini NO une videos: ejecuta código pero su entorno no tiene herramientas de video y te devuelve un comando de terminal. ChatGPT sí lo hace, en unos quince segundos.</a:t>
+              <a:t>COMPROBADO al preparar la clase, cuenta por cuenta:</a:t>
+            </a:r>
+          </a:p>
+          <a:p>
+            <a:r>
+              <a:t>· Institucional (UCaldas y UAM): NO tiene Crear video. El menú llega hasta Deep Research.</a:t>
+            </a:r>
+          </a:p>
+          <a:p>
+            <a:r>
+              <a:t>· Gmail personal GRATUITA: tampoco. Crear video no aparece en el menú. Esto fue una sorpresa y cambió el diseño de la clase.</a:t>
+            </a:r>
+          </a:p>
+          <a:p>
+            <a:r>
+              <a:t>· Gmail personal con plan PRO: sí lo tiene, unos 3 videos al día.</a:t>
+            </a:r>
+          </a:p>
+          <a:p>
+            <a:r>
+              <a:t>· GOOGLE FLOW (flow.google.com): según la página de precios de Google, cualquier cuenta de Google tiene 50 créditos diarios gratis, con Veo 3.1, avatares y personajes. No alcancé a completar la prueba de punta a punta porque Flow pedía volver a iniciar sesión. VERIFÍCALO TÚ ANTES DE LA CLASE: son dos minutos y decide por dónde corre la sesión.</a:t>
+            </a:r>
+          </a:p>
+          <a:p>
+            <a:r>
+              <a:t>· Gemini NO une videos: ejecuta código pero sin herramientas de video, y devuelve un comando de terminal. ChatGPT sí, en unos quince segundos.</a:t>
             </a:r>
           </a:p>
           <a:p/>
           <a:p>
             <a:r>
-              <a:t>Por eso la Ruta B de la diapositiva 13 no es un adorno: es el plan para medio salón.</a:t>
+              <a:t>Por eso la Ruta B de la diapositiva 13 no es un adorno.</a:t>
             </a:r>
           </a:p>
           <a:p/>
@@ -1757,7 +1790,7 @@
           <a:p/>
           <a:p>
             <a:r>
-              <a:t>«Eres guionista de videos educativos cortos. Escríbeme un guion de 150 palabras para un video de 60 segundos.</a:t>
+              <a:t>«Eres guionista de videos educativos cortos. Escríbeme un guion de 75 palabras para un video de 30 segundos.</a:t>
             </a:r>
           </a:p>
           <a:p>
@@ -1789,13 +1822,13 @@
           <a:p/>
           <a:p>
             <a:r>
-              <a:t>«Parte este guion en 6 frases de unas 25 palabras cada una. Cada frase tiene que poder decirse sola en 10 segundos y entenderse sin la anterior. Numéralas.»</a:t>
+              <a:t>«Parte este guion en 3 frases de unas 25 palabras cada una. Cada frase tiene que poder decirse sola en 10 segundos y entenderse sin la anterior. Numéralas.»</a:t>
             </a:r>
           </a:p>
           <a:p/>
           <a:p>
             <a:r>
-              <a:t>LA CUENTA: se habla a unas 150 palabras por minuto. 150 palabras = 1 minuto = 6 clips de 10 segundos = 25 palabras por clip. Hacer la cuenta en el tablero con ellos; es lo que vuelve el encargo concreto.</a:t>
+              <a:t>LA CUENTA: se habla a unas 150 palabras por minuto, o sea 25 palabras cada 10 segundos. Tres clips = 75 palabras = 30 segundos. Hacer la cuenta en el tablero con ellos; es lo que vuelve el encargo concreto.</a:t>
             </a:r>
           </a:p>
           <a:p/>
@@ -1959,7 +1992,7 @@
           <a:p/>
           <a:p>
             <a:r>
-              <a:t>La misma foto en los seis clips. Si cambian de foto, cambia la persona.</a:t>
+              <a:t>La misma foto en los tres clips. Si cambian de foto, cambia la persona.</a:t>
             </a:r>
           </a:p>
           <a:p/>
@@ -1971,7 +2004,7 @@
           <a:p/>
           <a:p>
             <a:r>
-              <a:t>PARA QUIEN NO QUIERA PONER SU CARA: que no adjunte nada y describa un personaje inventado, repitiendo la MISMA descripción palabra por palabra en los seis clips. Queda menos consistente, pero funciona. Nadie está obligado.</a:t>
+              <a:t>PARA QUIEN NO QUIERA PONER SU CARA: que no adjunte nada y describa un personaje inventado, repitiendo la MISMA descripción palabra por palabra en los tres clips. Queda menos consistente, pero funciona. Nadie está obligado.</a:t>
             </a:r>
           </a:p>
           <a:p/>
@@ -2053,6 +2086,22 @@
           <a:p/>
           <a:p>
             <a:r>
+              <a:t>DOS PUERTAS, el mismo prompt en las dos:</a:t>
+            </a:r>
+          </a:p>
+          <a:p>
+            <a:r>
+              <a:t>· GOOGLE FLOW (flow.google.com): entras con la cuenta de Google y tienes 50 créditos diarios gratis. Es la puerta que debería servirle a todo el salón.</a:t>
+            </a:r>
+          </a:p>
+          <a:p>
+            <a:r>
+              <a:t>· APP DE GEMINI: botón + → Crear video. Solo aparece con plan de pago; en cuenta gratuita no está.</a:t>
+            </a:r>
+          </a:p>
+          <a:p/>
+          <a:p>
+            <a:r>
               <a:t>PROMPT, uno por frase:</a:t>
             </a:r>
           </a:p>
@@ -2074,7 +2123,7 @@
           <a:p/>
           <a:p>
             <a:r>
-              <a:t>EL ERROR QUE VA A PASAR Y HAY QUE ANTICIPAR: si adjuntan la foto ANTES de activar Crear video, Gemini se sale del modo video y contesta por escrito. Me pasó dos veces al preparar la clase.</a:t>
+              <a:t>EL ERROR QUE VA A PASAR Y HAY QUE ANTICIPAR (solo en la app de Gemini): si adjuntan la foto ANTES de activar Crear video, Gemini se sale del modo video y contesta por escrito. Me pasó dos veces al preparar la clase.</a:t>
             </a:r>
           </a:p>
           <a:p>
@@ -5367,7 +5416,7 @@
                 </a:solidFill>
                 <a:latin typeface="Helvetica Neue"/>
               </a:rPr>
-              <a:t>Seis clips de diez segundos y un minuto de video con tu propia cara</a:t>
+              <a:t>Tres clips de diez segundos y medio minuto de video con tu propia cara</a:t>
             </a:r>
           </a:p>
         </p:txBody>
@@ -5664,7 +5713,7 @@
                 </a:solidFill>
                 <a:latin typeface="Helvetica Neue"/>
               </a:rPr>
-              <a:t>Los seis en un solo archivo</a:t>
+              <a:t>Los tres en un solo archivo</a:t>
             </a:r>
           </a:p>
         </p:txBody>
@@ -8998,7 +9047,7 @@
                 </a:solidFill>
                 <a:latin typeface="Helvetica Neue"/>
               </a:rPr>
-              <a:t>El guion completo de seis frases está en las notas.</a:t>
+              <a:t>El guion completo está en las notas. A ti te piden tres frases.</a:t>
             </a:r>
           </a:p>
         </p:txBody>
@@ -9501,7 +9550,7 @@
                 </a:solidFill>
                 <a:latin typeface="Helvetica Neue"/>
               </a:rPr>
-              <a:t>Un minuto: seis frases, seis clips, un archivo.</a:t>
+              <a:t>Treinta segundos: tres frases, tres clips, un archivo.</a:t>
             </a:r>
           </a:p>
           <a:p>
@@ -9741,7 +9790,7 @@
                 </a:solidFill>
                 <a:latin typeface="Helvetica Neue"/>
               </a:rPr>
-              <a:t>Fue decidir qué valía la pena contar, y decirlo en seis frases.</a:t>
+              <a:t>Fue decidir qué valía la pena contar, y decirlo en tres frases.</a:t>
             </a:r>
           </a:p>
         </p:txBody>
@@ -9994,7 +10043,7 @@
                 </a:solidFill>
                 <a:latin typeface="Helvetica Neue"/>
               </a:rPr>
-              <a:t>Un minuto, en seis pedazos</a:t>
+              <a:t>Medio minuto, en tres pedazos</a:t>
             </a:r>
           </a:p>
         </p:txBody>
@@ -10036,7 +10085,7 @@
                 </a:solidFill>
                 <a:latin typeface="Helvetica Neue"/>
               </a:rPr>
-              <a:t>Nadie hace un video de un minuto de una sola vez.</a:t>
+              <a:t>Nadie hace un video de corrido de una sola vez.</a:t>
             </a:r>
           </a:p>
           <a:p>
@@ -10055,7 +10104,7 @@
                 </a:solidFill>
                 <a:latin typeface="Helvetica Neue"/>
               </a:rPr>
-              <a:t>Se hacen seis de diez segundos y se pegan. Así sí se puede.</a:t>
+              <a:t>Se hacen tres de diez segundos y se pegan. Así sí se puede.</a:t>
             </a:r>
           </a:p>
         </p:txBody>
@@ -10187,7 +10236,7 @@
                 </a:solidFill>
                 <a:latin typeface="Helvetica Neue"/>
               </a:rPr>
-              <a:t>partido en 6 frases</a:t>
+              <a:t>partido en 3 frases</a:t>
             </a:r>
           </a:p>
         </p:txBody>
@@ -10409,7 +10458,7 @@
                 </a:solidFill>
                 <a:latin typeface="Helvetica Neue"/>
               </a:rPr>
-              <a:t>🎬 6 clips</a:t>
+              <a:t>🎬 3 clips</a:t>
             </a:r>
           </a:p>
         </p:txBody>
@@ -10902,7 +10951,7 @@
                 </a:solidFill>
                 <a:latin typeface="Helvetica Neue"/>
               </a:rPr>
-              <a:t>Partido en seis frases de 25 palabras</a:t>
+              <a:t>Partido en tres frases de 25 palabras</a:t>
             </a:r>
           </a:p>
         </p:txBody>
@@ -11238,7 +11287,7 @@
                 </a:solidFill>
                 <a:latin typeface="Helvetica Neue"/>
               </a:rPr>
-              <a:t>Uno por frase, en Gemini</a:t>
+              <a:t>Uno por frase, en Flow o Gemini</a:t>
             </a:r>
           </a:p>
         </p:txBody>
@@ -12191,7 +12240,7 @@
                 </a:solidFill>
                 <a:latin typeface="Helvetica Neue"/>
               </a:rPr>
-              <a:t>Los seis clips</a:t>
+              <a:t>Los tres clips</a:t>
             </a:r>
           </a:p>
         </p:txBody>
@@ -12233,7 +12282,7 @@
                 </a:solidFill>
                 <a:latin typeface="Helvetica Neue"/>
               </a:rPr>
-              <a:t>Gemini → Crear video</a:t>
+              <a:t>Google Flow (gratis) o Gemini (plan de pago)</a:t>
             </a:r>
           </a:p>
         </p:txBody>
@@ -12705,7 +12754,7 @@
                 </a:solidFill>
                 <a:latin typeface="Helvetica Neue"/>
               </a:rPr>
-              <a:t>La cuenta de la Universidad no tiene Crear video: hace falta Gmail personal.</a:t>
+              <a:t>En la app de Gemini, Crear video solo aparece con plan de pago.</a:t>
             </a:r>
           </a:p>
           <a:p>
@@ -12724,7 +12773,7 @@
                 </a:solidFill>
                 <a:latin typeface="Helvetica Neue"/>
               </a:rPr>
-              <a:t>Y el cupo cambia cada mes. Por eso existe la Ruta B.</a:t>
+              <a:t>La puerta gratuita es Google Flow. Y si falla, la Ruta B siempre sirve.</a:t>
             </a:r>
           </a:p>
         </p:txBody>
@@ -13458,7 +13507,7 @@
                 </a:solidFill>
                 <a:latin typeface="Helvetica Neue"/>
               </a:rPr>
-              <a:t>Y enseguida, partirlo en seis</a:t>
+              <a:t>Y enseguida, partirlo en tres</a:t>
             </a:r>
           </a:p>
         </p:txBody>
@@ -13548,7 +13597,7 @@
                 </a:solidFill>
                 <a:latin typeface="Helvetica Neue"/>
               </a:rPr>
-              <a:t>150 palabras  =  1 minuto</a:t>
+              <a:t>Se habla a 150 palabras por minuto</a:t>
             </a:r>
           </a:p>
           <a:p>
@@ -13567,7 +13616,7 @@
                 </a:solidFill>
                 <a:latin typeface="Helvetica Neue"/>
               </a:rPr>
-              <a:t>6 clips de 10 segundos  =  25 palabras cada uno</a:t>
+              <a:t>3 clips × 10 segundos  =  75 palabras</a:t>
             </a:r>
           </a:p>
           <a:p>
@@ -14193,7 +14242,7 @@
                 </a:solidFill>
                 <a:latin typeface="Helvetica Neue"/>
               </a:rPr>
-              <a:t>Después lo pules: «Limpia este dictado, quita las muletillas y déjalo en 150 palabras».</a:t>
+              <a:t>Después lo pules: «Limpia este dictado, quita las muletillas y déjalo en 75 palabras».</a:t>
             </a:r>
           </a:p>
         </p:txBody>
@@ -14380,7 +14429,7 @@
                 </a:solidFill>
                 <a:latin typeface="Helvetica Neue"/>
               </a:rPr>
-              <a:t>La misma en los seis clips</a:t>
+              <a:t>La misma en los tres clips</a:t>
             </a:r>
           </a:p>
         </p:txBody>
@@ -14618,7 +14667,7 @@
                 </a:solidFill>
                 <a:latin typeface="Helvetica Neue"/>
               </a:rPr>
-              <a:t>No adjuntes nada y describe un personaje. La misma descripción en los seis.</a:t>
+              <a:t>No adjuntes nada y describe un personaje. La misma descripción en los tres.</a:t>
             </a:r>
           </a:p>
         </p:txBody>
@@ -14890,7 +14939,7 @@
                 </a:solidFill>
                 <a:latin typeface="Helvetica Neue"/>
               </a:rPr>
-              <a:t>Uno por frase. Diez segundos, con voz incluida</a:t>
+              <a:t>Tres, uno por frase. Diez segundos cada uno, con voz incluida</a:t>
             </a:r>
           </a:p>
         </p:txBody>
@@ -14976,11 +15025,11 @@
             <a:r>
               <a:rPr sz="1900" b="1">
                 <a:solidFill>
-                  <a:srgbClr val="11406E"/>
-                </a:solidFill>
-                <a:latin typeface="Helvetica Neue"/>
-              </a:rPr>
-              <a:t>Botón +  →  Crear video  →  adjuntas la foto  →  escribes el prompt</a:t>
+                  <a:srgbClr val="ED7623"/>
+                </a:solidFill>
+                <a:latin typeface="Helvetica Neue"/>
+              </a:rPr>
+              <a:t>Google Flow — gratis, 50 créditos diarios</a:t>
             </a:r>
           </a:p>
           <a:p>
@@ -14992,6 +15041,15 @@
                 <a:spcPts val="400"/>
               </a:spcAft>
             </a:pPr>
+            <a:r>
+              <a:rPr sz="1900" b="1">
+                <a:solidFill>
+                  <a:srgbClr val="35789C"/>
+                </a:solidFill>
+                <a:latin typeface="Helvetica Neue"/>
+              </a:rPr>
+              <a:t>App de Gemini — solo con plan de pago</a:t>
+            </a:r>
           </a:p>
           <a:p>
             <a:pPr algn="l">
@@ -15002,6 +15060,16 @@
                 <a:spcPts val="400"/>
               </a:spcAft>
             </a:pPr>
+          </a:p>
+          <a:p>
+            <a:pPr algn="l">
+              <a:lnSpc>
+                <a:spcPct val="135000"/>
+              </a:lnSpc>
+              <a:spcAft>
+                <a:spcPts val="400"/>
+              </a:spcAft>
+            </a:pPr>
             <a:r>
               <a:rPr sz="1500" b="0">
                 <a:solidFill>
@@ -15009,7 +15077,7 @@
                 </a:solidFill>
                 <a:latin typeface="Helvetica Neue"/>
               </a:rPr>
-              <a:t>Dos a cuatro minutos por clip. El prompt completo está en las notas.</a:t>
+              <a:t>Dos a cuatro minutos por clip. Lánzalos seguidos. El prompt está en las notas.</a:t>
             </a:r>
           </a:p>
         </p:txBody>
@@ -15097,7 +15165,7 @@
                 </a:solidFill>
                 <a:latin typeface="Helvetica Neue"/>
               </a:rPr>
-              <a:t>El orden importa: primero Crear video, después la foto.</a:t>
+              <a:t>En la app de Gemini: primero Crear video, después la foto.</a:t>
             </a:r>
           </a:p>
           <a:p>
@@ -15116,7 +15184,7 @@
                 </a:solidFill>
                 <a:latin typeface="Helvetica Neue"/>
               </a:rPr>
-              <a:t>Al revés, Gemini se sale del modo video y te contesta por escrito.</a:t>
+              <a:t>Al revés se sale del modo video y te contesta por escrito.</a:t>
             </a:r>
           </a:p>
           <a:p>

</xml_diff>

<commit_message>
S6: Google Flow comprobado en cuenta gratuita, con los numeros reales
Probado de punta a punta en una cuenta de Google sin suscripcion: 50 creditos
diarios, 15 por clip de 10 s, o sea tres clips al dia, que es justo el encargo.
Salida 720p con audio verificado.

Dos advertencias que salieron de la prueba:
- Flow usa por defecto Veo 3.1 Lite (max 8 s) y fallo tres veces seguidas; hay
  que pedir "usa omni" para Omni 1.1 Flash y los 10 segundos
- no hay creditos para ensayar: tres tiros y ninguno de sobra, asi que el guion
  tiene que estar listo antes de generar

Co-Authored-By: Claude Opus 5 <noreply@anthropic.com>
</commit_message>
<xml_diff>
--- a/_static/sesion06/S06_audio_imagen_video.pptx
+++ b/_static/sesion06/S06_audio_imagen_video.pptx
@@ -1400,7 +1400,13 @@
           <a:p/>
           <a:p>
             <a:r>
-              <a:t>POR QUÉ TRES Y NO SEIS: cada clip tarda de dos a cuatro minutos en generarse y el cupo gratuito es limitado. Tres clips caben en la sesión y se llevan el video terminado; seis dejan a media clase sin acabar. Quien tenga cupo y ganas, que haga seis.</a:t>
+              <a:t>POR QUÉ TRES Y NO SEIS: no es una decisión pedagógica, es aritmética. Flow da 50 créditos gratis al día y cada clip de 10 segundos cuesta 15. Son tres clips, ni uno más.</a:t>
+            </a:r>
+          </a:p>
+          <a:p/>
+          <a:p>
+            <a:r>
+              <a:t>APROVECHA ESO: como no hay créditos para ensayar, el guion TIENE que estar bien antes de generar. Es el mejor argumento que vas a tener para que no se salten el paso 1.</a:t>
             </a:r>
           </a:p>
         </p:txBody>
@@ -1578,7 +1584,12 @@
           </a:p>
           <a:p>
             <a:r>
-              <a:t>· GOOGLE FLOW (flow.google.com): según la página de precios de Google, cualquier cuenta de Google tiene 50 créditos diarios gratis, con Veo 3.1, avatares y personajes. No alcancé a completar la prueba de punta a punta porque Flow pedía volver a iniciar sesión. VERIFÍCALO TÚ ANTES DE LA CLASE: son dos minutos y decide por dónde corre la sesión.</a:t>
+              <a:t>· GOOGLE FLOW (flow.google.com): PROBADO de punta a punta en una cuenta de Google gratuita, sin suscripción. Funciona. 50 créditos diarios que se renuevan a las 12:35 a.m. Un clip de 10 segundos con Omni 1.1 Flash cuesta 15 créditos: alcanza para TRES clips al día, exactamente el encargo. El clip sale en 720p con audio; 1080p y 4K piden plan.</a:t>
+            </a:r>
+          </a:p>
+          <a:p>
+            <a:r>
+              <a:t>· OJO CON EL MODELO EN FLOW: por defecto usa Veo 3.1 Lite, que solo llega a 8 segundos, y falló tres veces seguidas con un error genérico. Hay que pedir Omni 1.1 Flash explícitamente («usa omni»). Decírselo a los estudiantes de entrada, o van a perder clips en errores.</a:t>
             </a:r>
           </a:p>
           <a:p>
@@ -2091,12 +2102,24 @@
           </a:p>
           <a:p>
             <a:r>
-              <a:t>· GOOGLE FLOW (flow.google.com): entras con la cuenta de Google y tienes 50 créditos diarios gratis. Es la puerta que debería servirle a todo el salón.</a:t>
-            </a:r>
-          </a:p>
-          <a:p>
-            <a:r>
-              <a:t>· APP DE GEMINI: botón + → Crear video. Solo aparece con plan de pago; en cuenta gratuita no está.</a:t>
+              <a:t>· GOOGLE FLOW (flow.google.com): entras con la cuenta de Google y escribes el prompt. 50 créditos diarios; cada clip cuesta 15. Es la puerta de todo el salón.</a:t>
+            </a:r>
+          </a:p>
+          <a:p>
+            <a:r>
+              <a:t>· APP DE GEMINI: botón + → Crear video. Solo con plan de pago.</a:t>
+            </a:r>
+          </a:p>
+          <a:p/>
+          <a:p>
+            <a:r>
+              <a:t>EN FLOW HAY QUE PEDIR EL MODELO POR SU NOMBRE: el que usa por defecto (Veo 3.1 Lite) solo llega a 8 segundos y al probarlo falló tres veces. Hay que decirle «usa omni» para que use Omni 1.1 Flash y dé los 10 segundos. Dilo antes de soltarlos, o van a quemar créditos en errores.</a:t>
+            </a:r>
+          </a:p>
+          <a:p/>
+          <a:p>
+            <a:r>
+              <a:t>PARA DESCARGAR: menú ⋮ del clip → Descargar → 720p. Las de 1080p y 4K piden plan.</a:t>
             </a:r>
           </a:p>
           <a:p/>
@@ -12754,7 +12777,7 @@
                 </a:solidFill>
                 <a:latin typeface="Helvetica Neue"/>
               </a:rPr>
-              <a:t>En la app de Gemini, Crear video solo aparece con plan de pago.</a:t>
+              <a:t>La puerta gratuita es Google Flow: 50 créditos al día, 15 por clip.</a:t>
             </a:r>
           </a:p>
           <a:p>
@@ -12773,7 +12796,7 @@
                 </a:solidFill>
                 <a:latin typeface="Helvetica Neue"/>
               </a:rPr>
-              <a:t>La puerta gratuita es Google Flow. Y si falla, la Ruta B siempre sirve.</a:t>
+              <a:t>Te alcanza para tres clips. Ni uno de sobra: el guion tiene que estar listo antes.</a:t>
             </a:r>
           </a:p>
         </p:txBody>
@@ -15029,7 +15052,7 @@
                 </a:solidFill>
                 <a:latin typeface="Helvetica Neue"/>
               </a:rPr>
-              <a:t>Google Flow — gratis, 50 créditos diarios</a:t>
+              <a:t>Google Flow — 50 créditos al día, 15 por clip</a:t>
             </a:r>
           </a:p>
           <a:p>
@@ -15048,7 +15071,7 @@
                 </a:solidFill>
                 <a:latin typeface="Helvetica Neue"/>
               </a:rPr>
-              <a:t>App de Gemini — solo con plan de pago</a:t>
+              <a:t>Pídele «usa omni» o te dará solo 8 segundos</a:t>
             </a:r>
           </a:p>
           <a:p>

</xml_diff>

<commit_message>
S6: rehacer la sesion sobre Google Flow, con personajes y cuatro clips de 8 s
Probado en cuenta gratuita de Google. Flow hace las tres cosas: el personaje,
los clips y el montaje, asi que ChatGPT pasa a ser respaldo.

Costos medidos: crear personaje 0 creditos; clip de 8 s con Veo 3.1 Lite 10
creditos; clip de 10 s con Omni 15. Con 50 diarios el encargo son cuatro clips
de 8 s (40 creditos) y queda uno de repuesto.

Hallazgos que quedan documentados:
- hay que ADJUNTAR el personaje (+ -> Agregar a la instruccion); mencionarlo
  por escrito genera otra persona distinta
- el personaje arrastra el escenario donde se creo
- el personaje admite voz fija con instruccion de estilo, lo que resuelve que
  la voz cambie entre clips
- Veo 3.1 Lite falla seguido; Reintentar, o "usa omni"
- los Avatares de Flow no sirven todavia: experimentales y solo en ingles

Co-Authored-By: Claude Opus 5 <noreply@anthropic.com>
</commit_message>
<xml_diff>
--- a/_static/sesion06/S06_audio_imagen_video.pptx
+++ b/_static/sesion06/S06_audio_imagen_video.pptx
@@ -535,7 +535,7 @@
           <a:p/>
           <a:p>
             <a:r>
-              <a:t>Y OJO CON DÓNDE: en la app de Gemini, Crear video solo aparece con plan de pago. En cuenta gratuita NO está; lo comprobé. La puerta gratuita es Google Flow: 50 créditos diarios según la página de precios de Google. Verifícalo tú antes de la clase. Si no sirve ese día, Ruta B (diapositiva 13).</a:t>
+              <a:t>Y OJO CON DÓNDE: en la app de Gemini, Crear video solo aparece con plan de pago; en cuenta gratuita NO está. La herramienta de la clase es GOOGLE FLOW (flow.google.com): probado en cuenta gratuita, 50 créditos diarios. Flow hace las tres cosas: el personaje, los clips y el montaje.</a:t>
             </a:r>
           </a:p>
         </p:txBody>
@@ -605,42 +605,41 @@
           <a:lstStyle/>
           <a:p>
             <a:r>
-              <a:t>UNIR LOS CLIPS.</a:t>
+              <a:t>UNIR LOS CLIPS. Hay dos caminos y conviene enseñar el primero.</a:t>
             </a:r>
           </a:p>
           <a:p/>
           <a:p>
             <a:r>
-              <a:t>COMPROBADO: Gemini NO puede. Ejecuta código, pero su entorno no tiene herramientas de video, así que responde con un comando de terminal para que lo corras tú. Inútil aquí.</a:t>
+              <a:t>EN FLOW, que es lo más simple: al abrir un clip aparece una línea de tiempo abajo. El botón + al final del clip ofrece «Agregar clip». Van añadiendo los cuatro en orden y descargan el resultado. Todo en la misma herramienta, sin salir.</a:t>
             </a:r>
           </a:p>
           <a:p/>
           <a:p>
             <a:r>
-              <a:t>ChatGPT SÍ. Subes los clips y le dices:</a:t>
-            </a:r>
-          </a:p>
-          <a:p>
-            <a:r>
-              <a:t>«Une estos clips en un solo video, en este orden: clip1, clip2, clip3. Conserva el audio de cada uno. Déjame el archivo mp4 para descargar.»</a:t>
+              <a:t>DESCARGA: menú ⋮ del clip → Descargar → 720p. Las de 1080p y 4K piden plan.</a:t>
             </a:r>
           </a:p>
           <a:p/>
           <a:p>
             <a:r>
-              <a:t>Tarda unos quince segundos. Devuelve el MP4 completo, con el audio intacto y en 1280x720.</a:t>
+              <a:t>SI EL MONTAJE DE FLOW NO LES APARECE O FALLA, ChatGPT los une igual de bien:</a:t>
+            </a:r>
+          </a:p>
+          <a:p>
+            <a:r>
+              <a:t>«Une estos clips en un solo video, en este orden: clip1, clip2, clip3, clip4. Conserva el audio de cada uno. Déjame el archivo mp4 para descargar.»</a:t>
+            </a:r>
+          </a:p>
+          <a:p>
+            <a:r>
+              <a:t>Tarda unos quince segundos. Recodifica, así que pierde algo de calidad: no se nota.</a:t>
             </a:r>
           </a:p>
           <a:p/>
           <a:p>
             <a:r>
-              <a:t>Un detalle honesto: recodifica el video, así que pierde algo de calidad. Para la clase no se nota.</a:t>
-            </a:r>
-          </a:p>
-          <a:p/>
-          <a:p>
-            <a:r>
-              <a:t>ESTE ES UN BUEN MOMENTO PARA UNA PREGUNTA: ¿por qué una IA puede hacer esto y la otra no? Respuesta: no es "inteligencia", son las herramientas que le conectaron. Es la misma idea de la sesión del asistente.</a:t>
+              <a:t>DATO PARA UNA BUENA PREGUNTA: Gemini NO puede unir videos (ejecuta código pero sin herramientas de video, y devuelve un comando de terminal), ChatGPT SÍ. ¿Por qué una IA puede y la otra no? No es «inteligencia»: son las herramientas que le conectaron. Es la misma idea de la sesión del asistente.</a:t>
             </a:r>
           </a:p>
         </p:txBody>
@@ -710,37 +709,35 @@
           <a:lstStyle/>
           <a:p>
             <a:r>
-              <a:t>LA VOZ. Paso opcional: los clips ya vienen con voz.</a:t>
+              <a:t>LOS REMATES, en CapCut sobre el video ya unido. Opcional, pero sube mucho el resultado.</a:t>
             </a:r>
           </a:p>
           <a:p/>
           <a:p>
             <a:r>
-              <a:t>Cuándo vale la pena hacerlo aparte: cuando la voz que eligió Veo no les gusta, o cuando quieren que suene igual en los tres clips (Veo puede variarla un poco entre uno y otro).</a:t>
+              <a:t>1. Subtítulos automáticos. CapCut los saca del audio. REVISARLOS: siempre hay dos o tres palabras mal, y los nombres propios casi nunca salen bien.</a:t>
+            </a:r>
+          </a:p>
+          <a:p>
+            <a:r>
+              <a:t>2. Música de fondo al 10 o 15 % del volumen. Si compite con la voz, está muy alta.</a:t>
+            </a:r>
+          </a:p>
+          <a:p>
+            <a:r>
+              <a:t>3. Cortar los silencios entre clip y clip.</a:t>
             </a:r>
           </a:p>
           <a:p/>
           <a:p>
             <a:r>
-              <a:t>ELEVENLABS, capa gratuita: unos 10.000 créditos al mes, que son unos 10 minutos de audio. De sobra para un minuto. Tiene voces en español sin pedir tarjeta. No incluye licencia comercial: hay que mencionar la herramienta, cosa que ya hacen igual por la regla 2. Tampoco incluye clonación de voz: eso empieza en el plan de pago.</a:t>
+              <a:t>TRUCO PARA DECIR EN VOZ ALTA: música muy alta y subtítulos sin revisar son las dos marcas de un video amateur. Arreglar esas dos cosas sube el resultado más que cualquier efecto.</a:t>
             </a:r>
           </a:p>
           <a:p/>
           <a:p>
             <a:r>
-              <a:t>GOOGLE AI STUDIO: ojo, las voces filtradas como "Spanish" piden clave de pago. Filtrar por Gender y usar una genérica: leen español perfectamente.</a:t>
-            </a:r>
-          </a:p>
-          <a:p/>
-          <a:p>
-            <a:r>
-              <a:t>LA RUTA MÁS DIRECTA SI QUIEREN QUE SUENE COMO ELLOS: grabarse. Clonar la voz cuesta plata; grabarla no.</a:t>
-            </a:r>
-          </a:p>
-          <a:p/>
-          <a:p>
-            <a:r>
-              <a:t>INDICACIÓN DE ESTILO: «Español latinoamericano, tono cercano y pausado, como quien le explica algo a un amigo. No leas como noticiero.»</a:t>
+              <a:t>NOTA SOBRE LA VOZ: ya no hace falta un paso aparte. La voz va asignada al personaje desde el paso 2, y por eso suena igual en los cuatro clips. Si alguien quiere otra voz encima, ElevenLabs da unos 10 minutos gratis al mes, pero no es necesario.</a:t>
             </a:r>
           </a:p>
         </p:txBody>
@@ -810,29 +807,46 @@
           <a:lstStyle/>
           <a:p>
             <a:r>
-              <a:t>LOS REMATES, en CapCut sobre el video ya unido. Opcional, pero sube mucho el resultado.</a:t>
+              <a:t>LOS AVATARES DE FLOW. Vale la pena mencionarlo porque lo van a ver en el menú y van a preguntar.</a:t>
             </a:r>
           </a:p>
           <a:p/>
           <a:p>
             <a:r>
-              <a:t>1. Subtítulos automáticos. CapCut los saca del audio. REVISARLOS: siempre hay dos o tres palabras mal, y los nombres propios casi nunca salen bien.</a:t>
-            </a:r>
-          </a:p>
-          <a:p>
-            <a:r>
-              <a:t>2. Música de fondo al 10 o 15 % del volumen. Si compite con la voz, está muy alta.</a:t>
-            </a:r>
-          </a:p>
-          <a:p>
-            <a:r>
-              <a:t>3. Cortar los silencios entre clip y clip: Veo suele dejar medio segundo muerto al final de cada uno.</a:t>
+              <a:t>Flow tiene una opción de Avatares que graba tu cara Y TU VOZ con una videoselfie, y después te pone a ti en los videos. Suena perfecta para esta sesión. El titular que usa Google es, literalmente, «Tu rostro, tu voz, tu historia».</a:t>
             </a:r>
           </a:p>
           <a:p/>
           <a:p>
             <a:r>
-              <a:t>TRUCO PARA DECIR EN VOZ ALTA: música muy alta y subtítulos sin revisar son las dos marcas de un video amateur. Arreglar esas dos cosas sube el resultado más que cualquier efecto.</a:t>
+              <a:t>PERO NO SIRVE TODAVÍA, y lo dice la propia herramienta:</a:t>
+            </a:r>
+          </a:p>
+          <a:p>
+            <a:r>
+              <a:t>· Es una función EXPERIMENTAL.</a:t>
+            </a:r>
+          </a:p>
+          <a:p>
+            <a:r>
+              <a:t>· El registro SOLO ESTÁ DISPONIBLE EN INGLÉS.</a:t>
+            </a:r>
+          </a:p>
+          <a:p>
+            <a:r>
+              <a:t>· Avisa que «es posible que requiera varios intentos».</a:t>
+            </a:r>
+          </a:p>
+          <a:p/>
+          <a:p>
+            <a:r>
+              <a:t>Con treinta estudiantes y una hora, es inviable. Personajes hace el trabajo y es gratis.</a:t>
+            </a:r>
+          </a:p>
+          <a:p/>
+          <a:p>
+            <a:r>
+              <a:t>ESTE ES UN BUEN MOMENTO PARA UN PUNTO DE FONDO: estas herramientas cambian cada mes. Esta sesión se rehízo tres veces mientras se preparaba, porque lo que funcionaba una semana dejaba de funcionar la siguiente. No es un defecto de la clase: es el estado real del campo, y aprender a verificar antes de confiar es parte de lo que se llevan.</a:t>
             </a:r>
           </a:p>
         </p:txBody>
@@ -902,7 +916,7 @@
           <a:lstStyle/>
           <a:p>
             <a:r>
-              <a:t>LA RUTA B. Esta diapositiva no es un adorno: es el plan para quien solo tenga la cuenta institucional, se quede sin créditos, o para todo el salón si Flow no funciona ese día.</a:t>
+              <a:t>LA RUTA B. El plan para quien se quede sin créditos o para todo el salón si Flow no funciona ese día. Con 50 créditos y 10 por clip hay margen, pero los errores de Veo Lite se comen intentos.</a:t>
             </a:r>
           </a:p>
           <a:p/>
@@ -1022,7 +1036,7 @@
           <a:p/>
           <a:p>
             <a:r>
-              <a:t>EL GUION COMPLETO. El ejemplo que se proyecta son las dos primeras frases; a ellos se les piden tres. Dejo las seis por si quieres mostrar la versión larga:</a:t>
+              <a:t>EL GUION COMPLETO. El ejemplo que se proyecta son las dos primeras frases; a ellos se les piden cuatro. Dejo las seis por si quieres mostrar la versión larga:</a:t>
             </a:r>
           </a:p>
           <a:p>
@@ -1075,7 +1089,13 @@
           <a:p/>
           <a:p>
             <a:r>
-              <a:t>Si quieres las tres frases justas para el encargo de clase, usa la 1, la 2 y la 6: enganchan, explican y cierran con pregunta.</a:t>
+              <a:t>Si quieres las cuatro frases justas para el encargo de clase, usa la 1, la 2, la 5 y la 6: enganchan, explican, muestran la consecuencia y cierran con pregunta.</a:t>
+            </a:r>
+          </a:p>
+          <a:p/>
+          <a:p>
+            <a:r>
+              <a:t>OJO AL DESARMARLO: el ejemplo está hecho con la app de Gemini adjuntando una foto en cada clip, que era la ruta anterior. Ellos van a usar Personajes en Flow, que es más fácil. Dilo, para que no intenten copiar el procedimiento del ejemplo.</a:t>
             </a:r>
           </a:p>
         </p:txBody>
@@ -1188,17 +1208,17 @@
           </a:p>
           <a:p>
             <a:r>
-              <a:t>· «Crear video primero, la foto después» — a quien Gemini le contestó por escrito.</a:t>
-            </a:r>
-          </a:p>
-          <a:p>
-            <a:r>
-              <a:t>· «Es la misma foto en todos» — a quien le salieron tres personas distintas.</a:t>
-            </a:r>
-          </a:p>
-          <a:p>
-            <a:r>
-              <a:t>· «Prueba Flow» — a quien no le aparece Crear video en Gemini.</a:t>
+              <a:t>· «Adjunta el personaje, no lo escribas» — a quien le salieron personas distintas.</a:t>
+            </a:r>
+          </a:p>
+          <a:p>
+            <a:r>
+              <a:t>· «Dale Reintentar» — a quien le salió «Se produjo un error». Pasa seguido.</a:t>
+            </a:r>
+          </a:p>
+          <a:p>
+            <a:r>
+              <a:t>· «¿Dónde creaste el personaje?» — a quien le sale siempre el mismo fondo equivocado.</a:t>
             </a:r>
           </a:p>
           <a:p>
@@ -1400,13 +1420,13 @@
           <a:p/>
           <a:p>
             <a:r>
-              <a:t>POR QUÉ TRES Y NO SEIS: no es una decisión pedagógica, es aritmética. Flow da 50 créditos gratis al día y cada clip de 10 segundos cuesta 15. Son tres clips, ni uno más.</a:t>
+              <a:t>POR QUÉ CUATRO DE OCHO: es aritmética. Flow da 50 créditos gratis al día y un clip de 8 segundos cuesta 10. Cuatro clips son 40 y queda uno de repuesto, que se va a necesitar porque la herramienta falla seguido.</a:t>
             </a:r>
           </a:p>
           <a:p/>
           <a:p>
             <a:r>
-              <a:t>APROVECHA ESO: como no hay créditos para ensayar, el guion TIENE que estar bien antes de generar. Es el mejor argumento que vas a tener para que no se salten el paso 1.</a:t>
+              <a:t>APROVECHA ESO: el repuesto es para los errores, no para ensayar guiones. Como no hay créditos para probar a ver qué sale, el guion TIENE que estar bien antes de generar. Es el mejor argumento que vas a tener para que no se salten el paso 1.</a:t>
             </a:r>
           </a:p>
         </p:txBody>
@@ -1584,12 +1604,22 @@
           </a:p>
           <a:p>
             <a:r>
-              <a:t>· GOOGLE FLOW (flow.google.com): PROBADO de punta a punta en una cuenta de Google gratuita, sin suscripción. Funciona. 50 créditos diarios que se renuevan a las 12:35 a.m. Un clip de 10 segundos con Omni 1.1 Flash cuesta 15 créditos: alcanza para TRES clips al día, exactamente el encargo. El clip sale en 720p con audio; 1080p y 4K piden plan.</a:t>
-            </a:r>
-          </a:p>
-          <a:p>
-            <a:r>
-              <a:t>· OJO CON EL MODELO EN FLOW: por defecto usa Veo 3.1 Lite, que solo llega a 8 segundos, y falló tres veces seguidas con un error genérico. Hay que pedir Omni 1.1 Flash explícitamente («usa omni»). Decírselo a los estudiantes de entrada, o van a perder clips en errores.</a:t>
+              <a:t>· GOOGLE FLOW (flow.google.com): PROBADO de punta a punta en una cuenta de Google gratuita. 50 créditos diarios, se renuevan pasada la medianoche. Costos reales medidos: Veo 3.1 Lite (8 s) = 10 créditos; Omni 1.1 Flash (10 s) = 15. CREAR UN PERSONAJE NO GASTA NADA. Salida 720p con audio; 1080p y 4K piden plan.</a:t>
+            </a:r>
+          </a:p>
+          <a:p>
+            <a:r>
+              <a:t>· POR ESO EL ENCARGO ES DE CUATRO CLIPS DE OCHO: 40 créditos y queda uno de repuesto.</a:t>
+            </a:r>
+          </a:p>
+          <a:p>
+            <a:r>
+              <a:t>· VEO 3.1 LITE FALLA SEGUIDO: me dio «Se produjo un error» cuatro veces. Se le da Reintentar y suele salir. Si se pone imposible, escribir «usa omni» cambia a Omni 1.1 Flash, más confiable pero a 15 créditos (solo alcanzan tres clips).</a:t>
+            </a:r>
+          </a:p>
+          <a:p>
+            <a:r>
+              <a:t>· FLOW UNE LOS CLIPS SOLO: al abrir un clip hay una línea de tiempo con «+ → Agregar clip». Por eso ChatGPT queda de respaldo, no de paso obligatorio.</a:t>
             </a:r>
           </a:p>
           <a:p>
@@ -1801,7 +1831,7 @@
           <a:p/>
           <a:p>
             <a:r>
-              <a:t>«Eres guionista de videos educativos cortos. Escríbeme un guion de 75 palabras para un video de 30 segundos.</a:t>
+              <a:t>«Eres guionista de videos educativos cortos. Escríbeme un guion de 80 palabras para un video de 32 segundos.</a:t>
             </a:r>
           </a:p>
           <a:p>
@@ -1833,13 +1863,13 @@
           <a:p/>
           <a:p>
             <a:r>
-              <a:t>«Parte este guion en 3 frases de unas 25 palabras cada una. Cada frase tiene que poder decirse sola en 10 segundos y entenderse sin la anterior. Numéralas.»</a:t>
+              <a:t>«Parte este guion en 4 frases de unas 20 palabras cada una. Cada frase tiene que poder decirse sola en 8 segundos y entenderse sin la anterior. Numéralas.»</a:t>
             </a:r>
           </a:p>
           <a:p/>
           <a:p>
             <a:r>
-              <a:t>LA CUENTA: se habla a unas 150 palabras por minuto, o sea 25 palabras cada 10 segundos. Tres clips = 75 palabras = 30 segundos. Hacer la cuenta en el tablero con ellos; es lo que vuelve el encargo concreto.</a:t>
+              <a:t>LA CUENTA: se habla a unas 150 palabras por minuto, o sea 20 palabras cada 8 segundos. Cuatro clips = 80 palabras = 32 segundos. Hacer la cuenta en el tablero con ellos; es lo que vuelve el encargo concreto.</a:t>
             </a:r>
           </a:p>
           <a:p/>
@@ -1997,25 +2027,45 @@
           <a:lstStyle/>
           <a:p>
             <a:r>
-              <a:t>LA FOTO. Parece el paso tonto y es el que decide si el video se ve bien o ridículo.</a:t>
+              <a:t>EL PERSONAJE. Este paso es nuevo y es el que más mejora el resultado.</a:t>
             </a:r>
           </a:p>
           <a:p/>
           <a:p>
             <a:r>
-              <a:t>La misma foto en los tres clips. Si cambian de foto, cambia la persona.</a:t>
+              <a:t>En Flow, menú lateral → Personajes. CREARLO NO GASTA CRÉDITOS, así que pueden ensayar hasta que les guste. Decirlo en voz alta: es la única parte de la clase donde pueden experimentar sin costo.</a:t>
             </a:r>
           </a:p>
           <a:p/>
           <a:p>
             <a:r>
-              <a:t>Qué pedirles: de frente, cara bien iluminada, sin gafas de sol, sin otras personas en la imagen. Una foto de documento sirve; una foto de fiesta no.</a:t>
+              <a:t>DOS FORMAS:</a:t>
+            </a:r>
+          </a:p>
+          <a:p>
+            <a:r>
+              <a:t>· Con su foto: botón Subir, una foto de frente, bien iluminada, sin gafas de sol.</a:t>
+            </a:r>
+          </a:p>
+          <a:p>
+            <a:r>
+              <a:t>· Describiéndolo: escriben cómo es y Flow lo dibuja. Para quien no quiera poner su cara, y queda igual de consistente.</a:t>
             </a:r>
           </a:p>
           <a:p/>
           <a:p>
             <a:r>
-              <a:t>PARA QUIEN NO QUIERA PONER SU CARA: que no adjunte nada y describa un personaje inventado, repitiendo la MISMA descripción palabra por palabra en los tres clips. Queda menos consistente, pero funciona. Nadie está obligado.</a:t>
+              <a:t>DOS COSAS QUE HAY QUE HACER ANTES DE GASTAR UN CRÉDITO:</a:t>
+            </a:r>
+          </a:p>
+          <a:p>
+            <a:r>
+              <a:t>1. ASIGNARLE UNA VOZ. El botón «Selecciona una voz» deja elegir voz y escribir cómo debe sonar: «español latinoamericano, tono cercano y pausado, como quien le explica algo a un amigo». Así suena igual en los cuatro clips, que era justo el problema de la versión anterior.</a:t>
+            </a:r>
+          </a:p>
+          <a:p>
+            <a:r>
+              <a:t>2. CREARLO EN EL LUGAR CORRECTO. COMPROBADO: el personaje arrastra consigo el escenario donde se creó. Lo creé en una oficina, pedí un salón de clase, y salió en la oficina. Si quieren un laboratorio, el personaje hay que crearlo en el laboratorio.</a:t>
             </a:r>
           </a:p>
           <a:p/>
@@ -2097,72 +2147,57 @@
           <a:p/>
           <a:p>
             <a:r>
-              <a:t>DOS PUERTAS, el mismo prompt en las dos:</a:t>
-            </a:r>
-          </a:p>
-          <a:p>
-            <a:r>
-              <a:t>· GOOGLE FLOW (flow.google.com): entras con la cuenta de Google y escribes el prompt. 50 créditos diarios; cada clip cuesta 15. Es la puerta de todo el salón.</a:t>
-            </a:r>
-          </a:p>
-          <a:p>
-            <a:r>
-              <a:t>· APP DE GEMINI: botón + → Crear video. Solo con plan de pago.</a:t>
+              <a:t>PARA CADA CLIP, EN FLOW:</a:t>
+            </a:r>
+          </a:p>
+          <a:p>
+            <a:r>
+              <a:t>1. Botón + debajo del cuadro de texto.</a:t>
+            </a:r>
+          </a:p>
+          <a:p>
+            <a:r>
+              <a:t>2. Eligen su personaje de la lista y le dan «Agregar a la instrucción».</a:t>
+            </a:r>
+          </a:p>
+          <a:p>
+            <a:r>
+              <a:t>3. Escriben el prompt.</a:t>
             </a:r>
           </a:p>
           <a:p/>
           <a:p>
             <a:r>
-              <a:t>EN FLOW HAY QUE PEDIR EL MODELO POR SU NOMBRE: el que usa por defecto (Veo 3.1 Lite) solo llega a 8 segundos y al probarlo falló tres veces. Hay que decirle «usa omni» para que use Omni 1.1 Flash y dé los 10 segundos. Dilo antes de soltarlos, o van a quemar créditos en errores.</a:t>
+              <a:t>PROMPT (solo cambia la frase):</a:t>
+            </a:r>
+          </a:p>
+          <a:p>
+            <a:r>
+              <a:t>«Este personaje mira a la cámara y dice en español latinoamericano, tono cercano y pausado: "[una de sus frases]". Plano medio. Cámara fija. Sin texto en pantalla.»</a:t>
             </a:r>
           </a:p>
           <a:p/>
           <a:p>
             <a:r>
-              <a:t>PARA DESCARGAR: menú ⋮ del clip → Descargar → 720p. Las de 1080p y 4K piden plan.</a:t>
+              <a:t>EL ERROR QUE VA A PASAR Y HAY QUE ANTICIPAR: si solo ESCRIBEN «usa el personaje que acabo de crear», Flow genera OTRA PERSONA. Lo comprobé: salió un señor parecido pero con otra cara. Hay que ADJUNTARLO con el botón +. Cuando está bien, Flow responde que va a generar «utilizando la entidad del personaje referenciada»: que lo verifiquen en esa frase.</a:t>
             </a:r>
           </a:p>
           <a:p/>
           <a:p>
             <a:r>
-              <a:t>PROMPT, uno por frase:</a:t>
-            </a:r>
-          </a:p>
-          <a:p>
-            <a:r>
-              <a:t>«La persona de la foto, en plano medio dentro de [el lugar: un laboratorio, una sala de audiencias, un taller, una cancha, un afloramiento rocoso], con luz natural suave.</a:t>
-            </a:r>
-          </a:p>
-          <a:p>
-            <a:r>
-              <a:t>Mira a la cámara y dice en español latinoamericano, tono cercano y pausado: «[una de tus frases]»</a:t>
-            </a:r>
-          </a:p>
-          <a:p>
-            <a:r>
-              <a:t>Cámara fija, sin texto en pantalla.»</a:t>
+              <a:t>LOS CRÉDITOS: 50 al día, 10 por clip de 8 segundos. Cuatro clips y queda uno de repuesto.</a:t>
             </a:r>
           </a:p>
           <a:p/>
           <a:p>
             <a:r>
-              <a:t>EL ERROR QUE VA A PASAR Y HAY QUE ANTICIPAR (solo en la app de Gemini): si adjuntan la foto ANTES de activar Crear video, Gemini se sale del modo video y contesta por escrito. Me pasó dos veces al preparar la clase.</a:t>
-            </a:r>
-          </a:p>
-          <a:p>
-            <a:r>
-              <a:t>EL ORDEN ES: botón + → Crear video → DESPUÉS la foto → después el prompt.</a:t>
-            </a:r>
-          </a:p>
-          <a:p>
-            <a:r>
-              <a:t>Antes de enviar, que comprueben que abajo diga «Videos» y aparezca «Horizontal».</a:t>
+              <a:t>VEO 3.1 LITE FALLA SEGUIDO: «Se produjo un error» me salió cuatro veces. Se le da Reintentar. Si se pone imposible, escribir «usa omni» cambia a Omni 1.1 Flash (más confiable, 10 segundos, pero 15 créditos: solo alcanzan tres clips). Advertirlo ANTES de soltarlos.</a:t>
             </a:r>
           </a:p>
           <a:p/>
           <a:p>
             <a:r>
-              <a:t>Cada clip tarda entre dos y cuatro minutos. Que los lancen seguidos, no de a uno esperando.</a:t>
+              <a:t>Cada clip tarda de dos a cuatro minutos. Que los lancen seguidos, no de a uno esperando.</a:t>
             </a:r>
           </a:p>
         </p:txBody>
@@ -5439,7 +5474,7 @@
                 </a:solidFill>
                 <a:latin typeface="Helvetica Neue"/>
               </a:rPr>
-              <a:t>Tres clips de diez segundos y medio minuto de video con tu propia cara</a:t>
+              <a:t>Cuatro clips de ocho segundos y medio minuto de video con un personaje tuyo</a:t>
             </a:r>
           </a:p>
         </p:txBody>
@@ -5736,7 +5771,7 @@
                 </a:solidFill>
                 <a:latin typeface="Helvetica Neue"/>
               </a:rPr>
-              <a:t>Los tres en un solo archivo</a:t>
+              <a:t>Los cuatro en un solo archivo</a:t>
             </a:r>
           </a:p>
         </p:txBody>
@@ -5822,11 +5857,11 @@
             <a:r>
               <a:rPr sz="2200" b="1">
                 <a:solidFill>
-                  <a:srgbClr val="35789C"/>
-                </a:solidFill>
-                <a:latin typeface="Helvetica Neue"/>
-              </a:rPr>
-              <a:t>Gemini  ✕</a:t>
+                  <a:srgbClr val="ED7623"/>
+                </a:solidFill>
+                <a:latin typeface="Helvetica Neue"/>
+              </a:rPr>
+              <a:t>En Flow</a:t>
             </a:r>
           </a:p>
           <a:p>
@@ -5855,7 +5890,7 @@
                 </a:solidFill>
                 <a:latin typeface="Helvetica Neue"/>
               </a:rPr>
-              <a:t>Ejecuta código, pero sin herramientas de video. Te devuelve un comando de terminal.</a:t>
+              <a:t>Abres un clip, y en la línea de tiempo: + → Agregar clip. Sin salir de la herramienta.</a:t>
             </a:r>
           </a:p>
         </p:txBody>
@@ -5941,11 +5976,11 @@
             <a:r>
               <a:rPr sz="2200" b="1">
                 <a:solidFill>
-                  <a:srgbClr val="ED7623"/>
-                </a:solidFill>
-                <a:latin typeface="Helvetica Neue"/>
-              </a:rPr>
-              <a:t>ChatGPT  ✓</a:t>
+                  <a:srgbClr val="35789C"/>
+                </a:solidFill>
+                <a:latin typeface="Helvetica Neue"/>
+              </a:rPr>
+              <a:t>En ChatGPT</a:t>
             </a:r>
           </a:p>
           <a:p>
@@ -5974,7 +6009,7 @@
                 </a:solidFill>
                 <a:latin typeface="Helvetica Neue"/>
               </a:rPr>
-              <a:t>Subes los clips, le pides que los una. Quince segundos y te da el MP4.</a:t>
+              <a:t>Si lo de Flow falla: subes los clips y le pides que los una. Quince segundos.</a:t>
             </a:r>
           </a:p>
         </p:txBody>
@@ -6053,13 +6088,13 @@
               </a:spcAft>
             </a:pPr>
             <a:r>
-              <a:rPr sz="1600" b="1">
+              <a:rPr sz="1500" b="1">
                 <a:solidFill>
                   <a:srgbClr val="35789C"/>
                 </a:solidFill>
                 <a:latin typeface="Helvetica Neue"/>
               </a:rPr>
-              <a:t>¿Por qué una puede y la otra no? No es inteligencia: son las herramientas que le conectaron.</a:t>
+              <a:t>Gemini no puede unir videos y ChatGPT sí. No es inteligencia: son las herramientas que le conectaron.</a:t>
             </a:r>
           </a:p>
         </p:txBody>
@@ -6207,7 +6242,7 @@
                 </a:solidFill>
                 <a:latin typeface="Helvetica Neue"/>
               </a:rPr>
-              <a:t>La voz</a:t>
+              <a:t>Los remates</a:t>
             </a:r>
           </a:p>
         </p:txBody>
@@ -6246,7 +6281,7 @@
                 </a:solidFill>
                 <a:latin typeface="Helvetica Neue"/>
               </a:rPr>
-              <a:t>Opcional: los clips ya vienen con voz</a:t>
+              <a:t>En CapCut, sobre el video ya unido</a:t>
             </a:r>
           </a:p>
         </p:txBody>
@@ -6260,7 +6295,7 @@
         <p:spPr>
           <a:xfrm>
             <a:off x="2103120" y="2697480"/>
-            <a:ext cx="8778240" cy="1005840"/>
+            <a:ext cx="8778240" cy="822960"/>
           </a:xfrm>
           <a:prstGeom prst="roundRect">
             <a:avLst>
@@ -6307,8 +6342,8 @@
         </p:nvSpPr>
         <p:spPr>
           <a:xfrm>
-            <a:off x="2423160" y="2898648"/>
-            <a:ext cx="548640" cy="548640"/>
+            <a:off x="2468880" y="2825496"/>
+            <a:ext cx="457200" cy="548640"/>
           </a:xfrm>
           <a:prstGeom prst="rect">
             <a:avLst/>
@@ -6327,13 +6362,13 @@
               </a:spcAft>
             </a:pPr>
             <a:r>
-              <a:rPr sz="2600" b="1">
+              <a:rPr sz="2400" b="1">
                 <a:solidFill>
                   <a:srgbClr val="ED7623"/>
                 </a:solidFill>
                 <a:latin typeface="Helvetica Neue"/>
               </a:rPr>
-              <a:t>A</a:t>
+              <a:t>1</a:t>
             </a:r>
           </a:p>
         </p:txBody>
@@ -6346,8 +6381,8 @@
         </p:nvSpPr>
         <p:spPr>
           <a:xfrm>
-            <a:off x="3108960" y="2871216"/>
-            <a:ext cx="3017520" cy="457200"/>
+            <a:off x="3108960" y="2880360"/>
+            <a:ext cx="7498079" cy="548640"/>
           </a:xfrm>
           <a:prstGeom prst="rect">
             <a:avLst/>
@@ -6361,74 +6396,35 @@
           <a:lstStyle/>
           <a:p>
             <a:pPr algn="l">
+              <a:lnSpc>
+                <a:spcPct val="115000"/>
+              </a:lnSpc>
               <a:spcAft>
                 <a:spcPts val="600"/>
               </a:spcAft>
             </a:pPr>
             <a:r>
-              <a:rPr sz="2000" b="1">
+              <a:rPr sz="1800" b="0">
                 <a:solidFill>
                   <a:srgbClr val="11406E"/>
                 </a:solidFill>
                 <a:latin typeface="Helvetica Neue"/>
               </a:rPr>
-              <a:t>ElevenLabs</a:t>
-            </a:r>
-          </a:p>
-        </p:txBody>
-      </p:sp>
-      <p:sp>
-        <p:nvSpPr>
-          <p:cNvPr id="9" name="TextBox 8"/>
-          <p:cNvSpPr txBox="1"/>
-          <p:nvPr/>
-        </p:nvSpPr>
-        <p:spPr>
-          <a:xfrm>
-            <a:off x="6217920" y="2926080"/>
-            <a:ext cx="4480560" cy="548640"/>
-          </a:xfrm>
-          <a:prstGeom prst="rect">
-            <a:avLst/>
-          </a:prstGeom>
-          <a:noFill/>
-        </p:spPr>
-        <p:txBody>
-          <a:bodyPr wrap="square" lIns="0" rIns="0" tIns="0" bIns="0">
-            <a:spAutoFit/>
-          </a:bodyPr>
-          <a:lstStyle/>
-          <a:p>
-            <a:pPr algn="l">
-              <a:lnSpc>
-                <a:spcPct val="120000"/>
-              </a:lnSpc>
-              <a:spcAft>
-                <a:spcPts val="600"/>
-              </a:spcAft>
-            </a:pPr>
-            <a:r>
-              <a:rPr sz="1500" b="0">
-                <a:solidFill>
-                  <a:srgbClr val="6E6E6E"/>
-                </a:solidFill>
-                <a:latin typeface="Helvetica Neue"/>
-              </a:rPr>
-              <a:t>Gratis: ~10 min al mes. Voces en español sin pedir tarjeta</a:t>
-            </a:r>
-          </a:p>
-        </p:txBody>
-      </p:sp>
-      <p:sp>
-        <p:nvSpPr>
-          <p:cNvPr id="10" name="Rounded Rectangle 9"/>
+              <a:t>Subtítulos automáticos — y revisarlos</a:t>
+            </a:r>
+          </a:p>
+        </p:txBody>
+      </p:sp>
+      <p:sp>
+        <p:nvSpPr>
+          <p:cNvPr id="9" name="Rounded Rectangle 8"/>
           <p:cNvSpPr/>
           <p:nvPr/>
         </p:nvSpPr>
         <p:spPr>
           <a:xfrm>
-            <a:off x="2103120" y="3886200"/>
-            <a:ext cx="8778240" cy="1005840"/>
+            <a:off x="2103120" y="3703320"/>
+            <a:ext cx="8778240" cy="822960"/>
           </a:xfrm>
           <a:prstGeom prst="roundRect">
             <a:avLst>
@@ -6469,14 +6465,14 @@
       </p:sp>
       <p:sp>
         <p:nvSpPr>
-          <p:cNvPr id="11" name="TextBox 10"/>
+          <p:cNvPr id="10" name="TextBox 9"/>
           <p:cNvSpPr txBox="1"/>
           <p:nvPr/>
         </p:nvSpPr>
         <p:spPr>
           <a:xfrm>
-            <a:off x="2423160" y="4087368"/>
-            <a:ext cx="548640" cy="548640"/>
+            <a:off x="2468880" y="3831336"/>
+            <a:ext cx="457200" cy="548640"/>
           </a:xfrm>
           <a:prstGeom prst="rect">
             <a:avLst/>
@@ -6495,27 +6491,27 @@
               </a:spcAft>
             </a:pPr>
             <a:r>
-              <a:rPr sz="2600" b="1">
+              <a:rPr sz="2400" b="1">
                 <a:solidFill>
                   <a:srgbClr val="ED7623"/>
                 </a:solidFill>
                 <a:latin typeface="Helvetica Neue"/>
               </a:rPr>
-              <a:t>B</a:t>
-            </a:r>
-          </a:p>
-        </p:txBody>
-      </p:sp>
-      <p:sp>
-        <p:nvSpPr>
-          <p:cNvPr id="12" name="TextBox 11"/>
+              <a:t>2</a:t>
+            </a:r>
+          </a:p>
+        </p:txBody>
+      </p:sp>
+      <p:sp>
+        <p:nvSpPr>
+          <p:cNvPr id="11" name="TextBox 10"/>
           <p:cNvSpPr txBox="1"/>
           <p:nvPr/>
         </p:nvSpPr>
         <p:spPr>
           <a:xfrm>
-            <a:off x="3108960" y="4059936"/>
-            <a:ext cx="3017520" cy="457200"/>
+            <a:off x="3108960" y="3886200"/>
+            <a:ext cx="7498079" cy="548640"/>
           </a:xfrm>
           <a:prstGeom prst="rect">
             <a:avLst/>
@@ -6529,74 +6525,35 @@
           <a:lstStyle/>
           <a:p>
             <a:pPr algn="l">
+              <a:lnSpc>
+                <a:spcPct val="115000"/>
+              </a:lnSpc>
               <a:spcAft>
                 <a:spcPts val="600"/>
               </a:spcAft>
             </a:pPr>
             <a:r>
-              <a:rPr sz="2000" b="1">
+              <a:rPr sz="1800" b="0">
                 <a:solidFill>
                   <a:srgbClr val="11406E"/>
                 </a:solidFill>
                 <a:latin typeface="Helvetica Neue"/>
               </a:rPr>
-              <a:t>Google AI Studio</a:t>
-            </a:r>
-          </a:p>
-        </p:txBody>
-      </p:sp>
-      <p:sp>
-        <p:nvSpPr>
-          <p:cNvPr id="13" name="TextBox 12"/>
-          <p:cNvSpPr txBox="1"/>
-          <p:nvPr/>
-        </p:nvSpPr>
-        <p:spPr>
-          <a:xfrm>
-            <a:off x="6217920" y="4114800"/>
-            <a:ext cx="4480560" cy="548640"/>
-          </a:xfrm>
-          <a:prstGeom prst="rect">
-            <a:avLst/>
-          </a:prstGeom>
-          <a:noFill/>
-        </p:spPr>
-        <p:txBody>
-          <a:bodyPr wrap="square" lIns="0" rIns="0" tIns="0" bIns="0">
-            <a:spAutoFit/>
-          </a:bodyPr>
-          <a:lstStyle/>
-          <a:p>
-            <a:pPr algn="l">
-              <a:lnSpc>
-                <a:spcPct val="120000"/>
-              </a:lnSpc>
-              <a:spcAft>
-                <a:spcPts val="600"/>
-              </a:spcAft>
-            </a:pPr>
-            <a:r>
-              <a:rPr sz="1500" b="0">
-                <a:solidFill>
-                  <a:srgbClr val="6E6E6E"/>
-                </a:solidFill>
-                <a:latin typeface="Helvetica Neue"/>
-              </a:rPr>
-              <a:t>Filtra por Gender, no por Language: las de español cobran</a:t>
-            </a:r>
-          </a:p>
-        </p:txBody>
-      </p:sp>
-      <p:sp>
-        <p:nvSpPr>
-          <p:cNvPr id="14" name="Rounded Rectangle 13"/>
+              <a:t>Música de fondo al 10 o 15 % del volumen</a:t>
+            </a:r>
+          </a:p>
+        </p:txBody>
+      </p:sp>
+      <p:sp>
+        <p:nvSpPr>
+          <p:cNvPr id="12" name="Rounded Rectangle 11"/>
           <p:cNvSpPr/>
           <p:nvPr/>
         </p:nvSpPr>
         <p:spPr>
           <a:xfrm>
-            <a:off x="2103120" y="5074920"/>
-            <a:ext cx="8778240" cy="1005840"/>
+            <a:off x="2103120" y="4709160"/>
+            <a:ext cx="8778240" cy="822960"/>
           </a:xfrm>
           <a:prstGeom prst="roundRect">
             <a:avLst>
@@ -6637,14 +6594,14 @@
       </p:sp>
       <p:sp>
         <p:nvSpPr>
-          <p:cNvPr id="15" name="TextBox 14"/>
+          <p:cNvPr id="13" name="TextBox 12"/>
           <p:cNvSpPr txBox="1"/>
           <p:nvPr/>
         </p:nvSpPr>
         <p:spPr>
           <a:xfrm>
-            <a:off x="2423160" y="5276088"/>
-            <a:ext cx="548640" cy="548640"/>
+            <a:off x="2468880" y="4837176"/>
+            <a:ext cx="457200" cy="548640"/>
           </a:xfrm>
           <a:prstGeom prst="rect">
             <a:avLst/>
@@ -6663,27 +6620,27 @@
               </a:spcAft>
             </a:pPr>
             <a:r>
-              <a:rPr sz="2600" b="1">
+              <a:rPr sz="2400" b="1">
                 <a:solidFill>
                   <a:srgbClr val="ED7623"/>
                 </a:solidFill>
                 <a:latin typeface="Helvetica Neue"/>
               </a:rPr>
-              <a:t>C</a:t>
-            </a:r>
-          </a:p>
-        </p:txBody>
-      </p:sp>
-      <p:sp>
-        <p:nvSpPr>
-          <p:cNvPr id="16" name="TextBox 15"/>
+              <a:t>3</a:t>
+            </a:r>
+          </a:p>
+        </p:txBody>
+      </p:sp>
+      <p:sp>
+        <p:nvSpPr>
+          <p:cNvPr id="14" name="TextBox 13"/>
           <p:cNvSpPr txBox="1"/>
           <p:nvPr/>
         </p:nvSpPr>
         <p:spPr>
           <a:xfrm>
-            <a:off x="3108960" y="5248656"/>
-            <a:ext cx="3017520" cy="457200"/>
+            <a:off x="3108960" y="4892040"/>
+            <a:ext cx="7498079" cy="548640"/>
           </a:xfrm>
           <a:prstGeom prst="rect">
             <a:avLst/>
@@ -6697,32 +6654,81 @@
           <a:lstStyle/>
           <a:p>
             <a:pPr algn="l">
+              <a:lnSpc>
+                <a:spcPct val="115000"/>
+              </a:lnSpc>
               <a:spcAft>
                 <a:spcPts val="600"/>
               </a:spcAft>
             </a:pPr>
             <a:r>
-              <a:rPr sz="2000" b="1">
+              <a:rPr sz="1800" b="0">
                 <a:solidFill>
                   <a:srgbClr val="11406E"/>
                 </a:solidFill>
                 <a:latin typeface="Helvetica Neue"/>
               </a:rPr>
-              <a:t>Tu propia voz</a:t>
-            </a:r>
-          </a:p>
-        </p:txBody>
-      </p:sp>
-      <p:sp>
-        <p:nvSpPr>
-          <p:cNvPr id="17" name="TextBox 16"/>
+              <a:t>Cortar el silencio entre clip y clip</a:t>
+            </a:r>
+          </a:p>
+        </p:txBody>
+      </p:sp>
+      <p:sp>
+        <p:nvSpPr>
+          <p:cNvPr id="15" name="Rounded Rectangle 14"/>
+          <p:cNvSpPr/>
+          <p:nvPr/>
+        </p:nvSpPr>
+        <p:spPr>
+          <a:xfrm>
+            <a:off x="2103120" y="5806440"/>
+            <a:ext cx="8778240" cy="777240"/>
+          </a:xfrm>
+          <a:prstGeom prst="roundRect">
+            <a:avLst>
+              <a:gd name="adj" fmla="val 5000"/>
+            </a:avLst>
+          </a:prstGeom>
+          <a:solidFill>
+            <a:srgbClr val="ECF3F7"/>
+          </a:solidFill>
+          <a:ln>
+            <a:noFill/>
+          </a:ln>
+          <a:effectLst/>
+        </p:spPr>
+        <p:style>
+          <a:lnRef idx="1">
+            <a:schemeClr val="accent1"/>
+          </a:lnRef>
+          <a:fillRef idx="3">
+            <a:schemeClr val="accent1"/>
+          </a:fillRef>
+          <a:effectRef idx="2">
+            <a:schemeClr val="accent1"/>
+          </a:effectRef>
+          <a:fontRef idx="minor">
+            <a:schemeClr val="lt1"/>
+          </a:fontRef>
+        </p:style>
+        <p:txBody>
+          <a:bodyPr rtlCol="0" anchor="ctr"/>
+          <a:lstStyle/>
+          <a:p>
+            <a:pPr algn="ctr"/>
+          </a:p>
+        </p:txBody>
+      </p:sp>
+      <p:sp>
+        <p:nvSpPr>
+          <p:cNvPr id="16" name="TextBox 15"/>
           <p:cNvSpPr txBox="1"/>
           <p:nvPr/>
         </p:nvSpPr>
         <p:spPr>
           <a:xfrm>
-            <a:off x="6217920" y="5303520"/>
-            <a:ext cx="4480560" cy="548640"/>
+            <a:off x="2514600" y="6007608"/>
+            <a:ext cx="8138160" cy="457200"/>
           </a:xfrm>
           <a:prstGeom prst="rect">
             <a:avLst/>
@@ -6736,60 +6742,18 @@
           <a:lstStyle/>
           <a:p>
             <a:pPr algn="l">
-              <a:lnSpc>
-                <a:spcPct val="120000"/>
-              </a:lnSpc>
               <a:spcAft>
                 <a:spcPts val="600"/>
               </a:spcAft>
             </a:pPr>
             <a:r>
-              <a:rPr sz="1500" b="0">
-                <a:solidFill>
-                  <a:srgbClr val="6E6E6E"/>
-                </a:solidFill>
-                <a:latin typeface="Helvetica Neue"/>
-              </a:rPr>
-              <a:t>Grabarla es gratis. Clonarla cuesta</a:t>
-            </a:r>
-          </a:p>
-        </p:txBody>
-      </p:sp>
-      <p:sp>
-        <p:nvSpPr>
-          <p:cNvPr id="18" name="TextBox 17"/>
-          <p:cNvSpPr txBox="1"/>
-          <p:nvPr/>
-        </p:nvSpPr>
-        <p:spPr>
-          <a:xfrm>
-            <a:off x="2103120" y="6309360"/>
-            <a:ext cx="8778240" cy="457200"/>
-          </a:xfrm>
-          <a:prstGeom prst="rect">
-            <a:avLst/>
-          </a:prstGeom>
-          <a:noFill/>
-        </p:spPr>
-        <p:txBody>
-          <a:bodyPr wrap="square" lIns="0" rIns="0" tIns="0" bIns="0">
-            <a:spAutoFit/>
-          </a:bodyPr>
-          <a:lstStyle/>
-          <a:p>
-            <a:pPr algn="l">
-              <a:spcAft>
-                <a:spcPts val="600"/>
-              </a:spcAft>
-            </a:pPr>
-            <a:r>
-              <a:rPr sz="1500" b="0">
-                <a:solidFill>
-                  <a:srgbClr val="6E6E6E"/>
-                </a:solidFill>
-                <a:latin typeface="Helvetica Neue"/>
-              </a:rPr>
-              <a:t>Hazlo aparte solo si la voz de los clips no te gusta o te suena distinta entre uno y otro.</a:t>
+              <a:rPr sz="1600" b="1">
+                <a:solidFill>
+                  <a:srgbClr val="35789C"/>
+                </a:solidFill>
+                <a:latin typeface="Helvetica Neue"/>
+              </a:rPr>
+              <a:t>Música muy alta y subtítulos sin revisar: las dos marcas de un video amateur.</a:t>
             </a:r>
           </a:p>
         </p:txBody>
@@ -6872,8 +6836,8 @@
         </p:nvSpPr>
         <p:spPr>
           <a:xfrm>
-            <a:off x="822960" y="914400"/>
-            <a:ext cx="1828800" cy="1463040"/>
+            <a:off x="822960" y="502920"/>
+            <a:ext cx="10515600" cy="365760"/>
           </a:xfrm>
           <a:prstGeom prst="rect">
             <a:avLst/>
@@ -6892,13 +6856,13 @@
               </a:spcAft>
             </a:pPr>
             <a:r>
-              <a:rPr sz="9600" b="1">
-                <a:solidFill>
-                  <a:srgbClr val="ED7623"/>
-                </a:solidFill>
-                <a:latin typeface="Helvetica Neue"/>
-              </a:rPr>
-              <a:t>6</a:t>
+              <a:rPr sz="1200" b="1">
+                <a:solidFill>
+                  <a:srgbClr val="35789C"/>
+                </a:solidFill>
+                <a:latin typeface="Helvetica Neue"/>
+              </a:rPr>
+              <a:t>LO QUE VAN A VER Y VAN A PREGUNTAR</a:t>
             </a:r>
           </a:p>
         </p:txBody>
@@ -6911,8 +6875,8 @@
         </p:nvSpPr>
         <p:spPr>
           <a:xfrm>
-            <a:off x="2103120" y="1051560"/>
-            <a:ext cx="8686800" cy="822960"/>
+            <a:off x="822960" y="960120"/>
+            <a:ext cx="10607040" cy="1188720"/>
           </a:xfrm>
           <a:prstGeom prst="rect">
             <a:avLst/>
@@ -6926,18 +6890,21 @@
           <a:lstStyle/>
           <a:p>
             <a:pPr algn="l">
+              <a:lnSpc>
+                <a:spcPct val="105000"/>
+              </a:lnSpc>
               <a:spcAft>
                 <a:spcPts val="600"/>
               </a:spcAft>
             </a:pPr>
             <a:r>
-              <a:rPr sz="4400" b="1">
+              <a:rPr sz="3600" b="1">
                 <a:solidFill>
                   <a:srgbClr val="11406E"/>
                 </a:solidFill>
                 <a:latin typeface="Helvetica Neue"/>
               </a:rPr>
-              <a:t>Los remates</a:t>
+              <a:t>Los avatares de Flow: todavía no</a:t>
             </a:r>
           </a:p>
         </p:txBody>
@@ -6950,8 +6917,8 @@
         </p:nvSpPr>
         <p:spPr>
           <a:xfrm>
-            <a:off x="2103120" y="1965960"/>
-            <a:ext cx="8686800" cy="548640"/>
+            <a:off x="822960" y="2103120"/>
+            <a:ext cx="10515600" cy="731520"/>
           </a:xfrm>
           <a:prstGeom prst="rect">
             <a:avLst/>
@@ -6965,18 +6932,40 @@
           <a:lstStyle/>
           <a:p>
             <a:pPr algn="l">
-              <a:spcAft>
-                <a:spcPts val="600"/>
+              <a:lnSpc>
+                <a:spcPct val="130000"/>
+              </a:lnSpc>
+              <a:spcAft>
+                <a:spcPts val="200"/>
               </a:spcAft>
             </a:pPr>
             <a:r>
               <a:rPr sz="2000" b="0">
                 <a:solidFill>
-                  <a:srgbClr val="35789C"/>
-                </a:solidFill>
-                <a:latin typeface="Helvetica Neue"/>
-              </a:rPr>
-              <a:t>En CapCut, sobre el video ya unido</a:t>
+                  <a:srgbClr val="6E6E6E"/>
+                </a:solidFill>
+                <a:latin typeface="Helvetica Neue"/>
+              </a:rPr>
+              <a:t>Graba tu cara y tu voz con una videoselfie y te pone a ti en el video.</a:t>
+            </a:r>
+          </a:p>
+          <a:p>
+            <a:pPr algn="l">
+              <a:lnSpc>
+                <a:spcPct val="130000"/>
+              </a:lnSpc>
+              <a:spcAft>
+                <a:spcPts val="200"/>
+              </a:spcAft>
+            </a:pPr>
+            <a:r>
+              <a:rPr sz="2000" b="0">
+                <a:solidFill>
+                  <a:srgbClr val="6E6E6E"/>
+                </a:solidFill>
+                <a:latin typeface="Helvetica Neue"/>
+              </a:rPr>
+              <a:t>Suena perfecto. Pero la herramienta misma avisa que:</a:t>
             </a:r>
           </a:p>
         </p:txBody>
@@ -6989,8 +6978,8 @@
         </p:nvSpPr>
         <p:spPr>
           <a:xfrm>
-            <a:off x="2103120" y="2697480"/>
-            <a:ext cx="8778240" cy="822960"/>
+            <a:off x="822960" y="3429000"/>
+            <a:ext cx="10607040" cy="731520"/>
           </a:xfrm>
           <a:prstGeom prst="roundRect">
             <a:avLst>
@@ -7037,8 +7026,8 @@
         </p:nvSpPr>
         <p:spPr>
           <a:xfrm>
-            <a:off x="2468880" y="2825496"/>
-            <a:ext cx="457200" cy="548640"/>
+            <a:off x="1188720" y="3575304"/>
+            <a:ext cx="2743200" cy="457200"/>
           </a:xfrm>
           <a:prstGeom prst="rect">
             <a:avLst/>
@@ -7057,13 +7046,13 @@
               </a:spcAft>
             </a:pPr>
             <a:r>
-              <a:rPr sz="2400" b="1">
+              <a:rPr sz="1900" b="1">
                 <a:solidFill>
                   <a:srgbClr val="ED7623"/>
                 </a:solidFill>
                 <a:latin typeface="Helvetica Neue"/>
               </a:rPr>
-              <a:t>1</a:t>
+              <a:t>Experimental</a:t>
             </a:r>
           </a:p>
         </p:txBody>
@@ -7076,8 +7065,8 @@
         </p:nvSpPr>
         <p:spPr>
           <a:xfrm>
-            <a:off x="3108960" y="2880360"/>
-            <a:ext cx="7498079" cy="548640"/>
+            <a:off x="4114800" y="3602736"/>
+            <a:ext cx="6949440" cy="457200"/>
           </a:xfrm>
           <a:prstGeom prst="rect">
             <a:avLst/>
@@ -7091,21 +7080,18 @@
           <a:lstStyle/>
           <a:p>
             <a:pPr algn="l">
-              <a:lnSpc>
-                <a:spcPct val="115000"/>
-              </a:lnSpc>
               <a:spcAft>
                 <a:spcPts val="600"/>
               </a:spcAft>
             </a:pPr>
             <a:r>
-              <a:rPr sz="1800" b="0">
-                <a:solidFill>
-                  <a:srgbClr val="11406E"/>
-                </a:solidFill>
-                <a:latin typeface="Helvetica Neue"/>
-              </a:rPr>
-              <a:t>Subtítulos automáticos — y revisarlos</a:t>
+              <a:rPr sz="1600" b="0">
+                <a:solidFill>
+                  <a:srgbClr val="6E6E6E"/>
+                </a:solidFill>
+                <a:latin typeface="Helvetica Neue"/>
+              </a:rPr>
+              <a:t>La propia pantalla lo dice</a:t>
             </a:r>
           </a:p>
         </p:txBody>
@@ -7118,8 +7104,8 @@
         </p:nvSpPr>
         <p:spPr>
           <a:xfrm>
-            <a:off x="2103120" y="3703320"/>
-            <a:ext cx="8778240" cy="822960"/>
+            <a:off x="822960" y="4297680"/>
+            <a:ext cx="10607040" cy="731520"/>
           </a:xfrm>
           <a:prstGeom prst="roundRect">
             <a:avLst>
@@ -7166,8 +7152,8 @@
         </p:nvSpPr>
         <p:spPr>
           <a:xfrm>
-            <a:off x="2468880" y="3831336"/>
-            <a:ext cx="457200" cy="548640"/>
+            <a:off x="1188720" y="4443984"/>
+            <a:ext cx="2743200" cy="457200"/>
           </a:xfrm>
           <a:prstGeom prst="rect">
             <a:avLst/>
@@ -7186,13 +7172,13 @@
               </a:spcAft>
             </a:pPr>
             <a:r>
-              <a:rPr sz="2400" b="1">
+              <a:rPr sz="1900" b="1">
                 <a:solidFill>
                   <a:srgbClr val="ED7623"/>
                 </a:solidFill>
                 <a:latin typeface="Helvetica Neue"/>
               </a:rPr>
-              <a:t>2</a:t>
+              <a:t>Solo en inglés</a:t>
             </a:r>
           </a:p>
         </p:txBody>
@@ -7205,8 +7191,8 @@
         </p:nvSpPr>
         <p:spPr>
           <a:xfrm>
-            <a:off x="3108960" y="3886200"/>
-            <a:ext cx="7498079" cy="548640"/>
+            <a:off x="4114800" y="4471416"/>
+            <a:ext cx="6949440" cy="457200"/>
           </a:xfrm>
           <a:prstGeom prst="rect">
             <a:avLst/>
@@ -7220,21 +7206,18 @@
           <a:lstStyle/>
           <a:p>
             <a:pPr algn="l">
-              <a:lnSpc>
-                <a:spcPct val="115000"/>
-              </a:lnSpc>
               <a:spcAft>
                 <a:spcPts val="600"/>
               </a:spcAft>
             </a:pPr>
             <a:r>
-              <a:rPr sz="1800" b="0">
-                <a:solidFill>
-                  <a:srgbClr val="11406E"/>
-                </a:solidFill>
-                <a:latin typeface="Helvetica Neue"/>
-              </a:rPr>
-              <a:t>Música de fondo al 10 o 15 % del volumen</a:t>
+              <a:rPr sz="1600" b="0">
+                <a:solidFill>
+                  <a:srgbClr val="6E6E6E"/>
+                </a:solidFill>
+                <a:latin typeface="Helvetica Neue"/>
+              </a:rPr>
+              <a:t>El registro no está disponible en español</a:t>
             </a:r>
           </a:p>
         </p:txBody>
@@ -7247,8 +7230,8 @@
         </p:nvSpPr>
         <p:spPr>
           <a:xfrm>
-            <a:off x="2103120" y="4709160"/>
-            <a:ext cx="8778240" cy="822960"/>
+            <a:off x="822960" y="5166360"/>
+            <a:ext cx="10607040" cy="731520"/>
           </a:xfrm>
           <a:prstGeom prst="roundRect">
             <a:avLst>
@@ -7295,8 +7278,8 @@
         </p:nvSpPr>
         <p:spPr>
           <a:xfrm>
-            <a:off x="2468880" y="4837176"/>
-            <a:ext cx="457200" cy="548640"/>
+            <a:off x="1188720" y="5312664"/>
+            <a:ext cx="2743200" cy="457200"/>
           </a:xfrm>
           <a:prstGeom prst="rect">
             <a:avLst/>
@@ -7315,13 +7298,13 @@
               </a:spcAft>
             </a:pPr>
             <a:r>
-              <a:rPr sz="2400" b="1">
+              <a:rPr sz="1900" b="1">
                 <a:solidFill>
                   <a:srgbClr val="ED7623"/>
                 </a:solidFill>
                 <a:latin typeface="Helvetica Neue"/>
               </a:rPr>
-              <a:t>3</a:t>
+              <a:t>Varios intentos</a:t>
             </a:r>
           </a:p>
         </p:txBody>
@@ -7334,8 +7317,8 @@
         </p:nvSpPr>
         <p:spPr>
           <a:xfrm>
-            <a:off x="3108960" y="4892040"/>
-            <a:ext cx="7498079" cy="548640"/>
+            <a:off x="4114800" y="5340096"/>
+            <a:ext cx="6949440" cy="457200"/>
           </a:xfrm>
           <a:prstGeom prst="rect">
             <a:avLst/>
@@ -7349,21 +7332,18 @@
           <a:lstStyle/>
           <a:p>
             <a:pPr algn="l">
-              <a:lnSpc>
-                <a:spcPct val="115000"/>
-              </a:lnSpc>
               <a:spcAft>
                 <a:spcPts val="600"/>
               </a:spcAft>
             </a:pPr>
             <a:r>
-              <a:rPr sz="1800" b="0">
-                <a:solidFill>
-                  <a:srgbClr val="11406E"/>
-                </a:solidFill>
-                <a:latin typeface="Helvetica Neue"/>
-              </a:rPr>
-              <a:t>Cortar el silencio entre clip y clip</a:t>
+              <a:rPr sz="1600" b="0">
+                <a:solidFill>
+                  <a:srgbClr val="6E6E6E"/>
+                </a:solidFill>
+                <a:latin typeface="Helvetica Neue"/>
+              </a:rPr>
+              <a:t>«Es posible que requiera varios intentos»</a:t>
             </a:r>
           </a:p>
         </p:txBody>
@@ -7376,8 +7356,8 @@
         </p:nvSpPr>
         <p:spPr>
           <a:xfrm>
-            <a:off x="2103120" y="5806440"/>
-            <a:ext cx="8778240" cy="777240"/>
+            <a:off x="822960" y="6126480"/>
+            <a:ext cx="10515600" cy="685800"/>
           </a:xfrm>
           <a:prstGeom prst="roundRect">
             <a:avLst>
@@ -7385,7 +7365,7 @@
             </a:avLst>
           </a:prstGeom>
           <a:solidFill>
-            <a:srgbClr val="ECF3F7"/>
+            <a:srgbClr val="FDF0E6"/>
           </a:solidFill>
           <a:ln>
             <a:noFill/>
@@ -7422,8 +7402,8 @@
         </p:nvSpPr>
         <p:spPr>
           <a:xfrm>
-            <a:off x="2514600" y="6007608"/>
-            <a:ext cx="8138160" cy="457200"/>
+            <a:off x="1234440" y="6291072"/>
+            <a:ext cx="9692640" cy="457200"/>
           </a:xfrm>
           <a:prstGeom prst="rect">
             <a:avLst/>
@@ -7444,11 +7424,11 @@
             <a:r>
               <a:rPr sz="1600" b="1">
                 <a:solidFill>
-                  <a:srgbClr val="35789C"/>
-                </a:solidFill>
-                <a:latin typeface="Helvetica Neue"/>
-              </a:rPr>
-              <a:t>Música muy alta y subtítulos sin revisar: las dos marcas de un video amateur.</a:t>
+                  <a:srgbClr val="ED7623"/>
+                </a:solidFill>
+                <a:latin typeface="Helvetica Neue"/>
+              </a:rPr>
+              <a:t>Personajes hace el trabajo, es gratis, y funciona en español.</a:t>
             </a:r>
           </a:p>
         </p:txBody>
@@ -9070,7 +9050,7 @@
                 </a:solidFill>
                 <a:latin typeface="Helvetica Neue"/>
               </a:rPr>
-              <a:t>El guion completo está en las notas. A ti te piden tres frases.</a:t>
+              <a:t>El guion completo está en las notas. A ti te piden cuatro frases.</a:t>
             </a:r>
           </a:p>
         </p:txBody>
@@ -9573,7 +9553,7 @@
                 </a:solidFill>
                 <a:latin typeface="Helvetica Neue"/>
               </a:rPr>
-              <a:t>Treinta segundos: tres frases, tres clips, un archivo.</a:t>
+              <a:t>Medio minuto: cuatro frases, cuatro clips, un archivo.</a:t>
             </a:r>
           </a:p>
           <a:p>
@@ -9813,7 +9793,7 @@
                 </a:solidFill>
                 <a:latin typeface="Helvetica Neue"/>
               </a:rPr>
-              <a:t>Fue decidir qué valía la pena contar, y decirlo en tres frases.</a:t>
+              <a:t>Fue decidir qué valía la pena contar, y decirlo en cuatro frases.</a:t>
             </a:r>
           </a:p>
         </p:txBody>
@@ -10066,7 +10046,7 @@
                 </a:solidFill>
                 <a:latin typeface="Helvetica Neue"/>
               </a:rPr>
-              <a:t>Medio minuto, en tres pedazos</a:t>
+              <a:t>Medio minuto, en cuatro pedazos</a:t>
             </a:r>
           </a:p>
         </p:txBody>
@@ -10127,7 +10107,7 @@
                 </a:solidFill>
                 <a:latin typeface="Helvetica Neue"/>
               </a:rPr>
-              <a:t>Se hacen tres de diez segundos y se pegan. Así sí se puede.</a:t>
+              <a:t>Se hacen cuatro de ocho segundos y se pegan. Así sí se puede.</a:t>
             </a:r>
           </a:p>
         </p:txBody>
@@ -10259,7 +10239,7 @@
                 </a:solidFill>
                 <a:latin typeface="Helvetica Neue"/>
               </a:rPr>
-              <a:t>partido en 3 frases</a:t>
+              <a:t>partido en 4 frases</a:t>
             </a:r>
           </a:p>
         </p:txBody>
@@ -10349,7 +10329,7 @@
                 </a:solidFill>
                 <a:latin typeface="Helvetica Neue"/>
               </a:rPr>
-              <a:t>🧑 Tu foto</a:t>
+              <a:t>🧑 Personaje</a:t>
             </a:r>
           </a:p>
         </p:txBody>
@@ -10391,7 +10371,7 @@
                 </a:solidFill>
                 <a:latin typeface="Helvetica Neue"/>
               </a:rPr>
-              <a:t>la misma en todos</a:t>
+              <a:t>gratis, y con voz</a:t>
             </a:r>
           </a:p>
         </p:txBody>
@@ -10481,7 +10461,7 @@
                 </a:solidFill>
                 <a:latin typeface="Helvetica Neue"/>
               </a:rPr>
-              <a:t>🎬 3 clips</a:t>
+              <a:t>🎬 4 clips</a:t>
             </a:r>
           </a:p>
         </p:txBody>
@@ -10523,7 +10503,7 @@
                 </a:solidFill>
                 <a:latin typeface="Helvetica Neue"/>
               </a:rPr>
-              <a:t>10 segundos cada uno</a:t>
+              <a:t>8 segundos cada uno</a:t>
             </a:r>
           </a:p>
         </p:txBody>
@@ -10655,7 +10635,7 @@
                 </a:solidFill>
                 <a:latin typeface="Helvetica Neue"/>
               </a:rPr>
-              <a:t>en ChatGPT</a:t>
+              <a:t>en el mismo Flow</a:t>
             </a:r>
           </a:p>
         </p:txBody>
@@ -10974,7 +10954,7 @@
                 </a:solidFill>
                 <a:latin typeface="Helvetica Neue"/>
               </a:rPr>
-              <a:t>Partido en tres frases de 25 palabras</a:t>
+              <a:t>Partido en cuatro frases de 20 palabras</a:t>
             </a:r>
           </a:p>
         </p:txBody>
@@ -11100,7 +11080,7 @@
                 </a:solidFill>
                 <a:latin typeface="Helvetica Neue"/>
               </a:rPr>
-              <a:t>Tu foto</a:t>
+              <a:t>Tu personaje</a:t>
             </a:r>
           </a:p>
         </p:txBody>
@@ -11142,7 +11122,7 @@
                 </a:solidFill>
                 <a:latin typeface="Helvetica Neue"/>
               </a:rPr>
-              <a:t>Una sola, de frente. La misma siempre</a:t>
+              <a:t>Se crea en Flow, gratis, y lleva voz</a:t>
             </a:r>
           </a:p>
         </p:txBody>
@@ -11310,7 +11290,7 @@
                 </a:solidFill>
                 <a:latin typeface="Helvetica Neue"/>
               </a:rPr>
-              <a:t>Uno por frase, en Flow o Gemini</a:t>
+              <a:t>Uno por frase, adjuntando el personaje</a:t>
             </a:r>
           </a:p>
         </p:txBody>
@@ -11478,7 +11458,7 @@
                 </a:solidFill>
                 <a:latin typeface="Helvetica Neue"/>
               </a:rPr>
-              <a:t>En ChatGPT, en un solo archivo</a:t>
+              <a:t>En Flow mismo, o en ChatGPT</a:t>
             </a:r>
           </a:p>
         </p:txBody>
@@ -11604,7 +11584,7 @@
                 </a:solidFill>
                 <a:latin typeface="Helvetica Neue"/>
               </a:rPr>
-              <a:t>La voz  (opcional)</a:t>
+              <a:t>Remates  (opcional)</a:t>
             </a:r>
           </a:p>
         </p:txBody>
@@ -11646,7 +11626,7 @@
                 </a:solidFill>
                 <a:latin typeface="Helvetica Neue"/>
               </a:rPr>
-              <a:t>Otra narración encima</a:t>
+              <a:t>Subtítulos y música en CapCut</a:t>
             </a:r>
           </a:p>
         </p:txBody>
@@ -11772,7 +11752,7 @@
                 </a:solidFill>
                 <a:latin typeface="Helvetica Neue"/>
               </a:rPr>
-              <a:t>Remates  (opcional)</a:t>
+              <a:t>Ruta B  (opcional)</a:t>
             </a:r>
           </a:p>
         </p:txBody>
@@ -11814,7 +11794,7 @@
                 </a:solidFill>
                 <a:latin typeface="Helvetica Neue"/>
               </a:rPr>
-              <a:t>Subtítulos y música</a:t>
+              <a:t>Si no hay créditos ese día</a:t>
             </a:r>
           </a:p>
         </p:txBody>
@@ -12263,7 +12243,7 @@
                 </a:solidFill>
                 <a:latin typeface="Helvetica Neue"/>
               </a:rPr>
-              <a:t>Los tres clips</a:t>
+              <a:t>Personaje, clips y montaje</a:t>
             </a:r>
           </a:p>
         </p:txBody>
@@ -12305,7 +12285,7 @@
                 </a:solidFill>
                 <a:latin typeface="Helvetica Neue"/>
               </a:rPr>
-              <a:t>Google Flow (gratis) o Gemini (plan de pago)</a:t>
+              <a:t>Google Flow · 50 créditos gratis al día</a:t>
             </a:r>
           </a:p>
         </p:txBody>
@@ -12391,7 +12371,7 @@
                 </a:solidFill>
                 <a:latin typeface="Helvetica Neue"/>
               </a:rPr>
-              <a:t>Unirlos</a:t>
+              <a:t>Unirlos, si Flow falla</a:t>
             </a:r>
           </a:p>
         </p:txBody>
@@ -12519,7 +12499,7 @@
                 </a:solidFill>
                 <a:latin typeface="Helvetica Neue"/>
               </a:rPr>
-              <a:t>Voz aparte (opcional)</a:t>
+              <a:t>Subtítulos y música (opcional)</a:t>
             </a:r>
           </a:p>
         </p:txBody>
@@ -12561,134 +12541,6 @@
                 </a:solidFill>
                 <a:latin typeface="Helvetica Neue"/>
               </a:rPr>
-              <a:t>ElevenLabs</a:t>
-            </a:r>
-          </a:p>
-        </p:txBody>
-      </p:sp>
-      <p:sp>
-        <p:nvSpPr>
-          <p:cNvPr id="19" name="Rectangle 18"/>
-          <p:cNvSpPr/>
-          <p:nvPr/>
-        </p:nvSpPr>
-        <p:spPr>
-          <a:xfrm>
-            <a:off x="822960" y="4873752"/>
-            <a:ext cx="10607040" cy="7315"/>
-          </a:xfrm>
-          <a:prstGeom prst="rect">
-            <a:avLst/>
-          </a:prstGeom>
-          <a:solidFill>
-            <a:srgbClr val="E3E0DA"/>
-          </a:solidFill>
-          <a:ln>
-            <a:noFill/>
-          </a:ln>
-          <a:effectLst/>
-        </p:spPr>
-        <p:style>
-          <a:lnRef idx="1">
-            <a:schemeClr val="accent1"/>
-          </a:lnRef>
-          <a:fillRef idx="3">
-            <a:schemeClr val="accent1"/>
-          </a:fillRef>
-          <a:effectRef idx="2">
-            <a:schemeClr val="accent1"/>
-          </a:effectRef>
-          <a:fontRef idx="minor">
-            <a:schemeClr val="lt1"/>
-          </a:fontRef>
-        </p:style>
-        <p:txBody>
-          <a:bodyPr rtlCol="0" anchor="ctr"/>
-          <a:lstStyle/>
-          <a:p>
-            <a:pPr algn="ctr"/>
-          </a:p>
-        </p:txBody>
-      </p:sp>
-      <p:sp>
-        <p:nvSpPr>
-          <p:cNvPr id="20" name="TextBox 19"/>
-          <p:cNvSpPr txBox="1"/>
-          <p:nvPr/>
-        </p:nvSpPr>
-        <p:spPr>
-          <a:xfrm>
-            <a:off x="822960" y="4937760"/>
-            <a:ext cx="4572000" cy="566928"/>
-          </a:xfrm>
-          <a:prstGeom prst="rect">
-            <a:avLst/>
-          </a:prstGeom>
-          <a:noFill/>
-        </p:spPr>
-        <p:txBody>
-          <a:bodyPr wrap="square" lIns="0" rIns="0" tIns="0" bIns="0">
-            <a:spAutoFit/>
-          </a:bodyPr>
-          <a:lstStyle/>
-          <a:p>
-            <a:pPr algn="l">
-              <a:lnSpc>
-                <a:spcPct val="112000"/>
-              </a:lnSpc>
-              <a:spcAft>
-                <a:spcPts val="0"/>
-              </a:spcAft>
-            </a:pPr>
-            <a:r>
-              <a:rPr sz="1700" b="1">
-                <a:solidFill>
-                  <a:srgbClr val="ED7623"/>
-                </a:solidFill>
-                <a:latin typeface="Helvetica Neue"/>
-              </a:rPr>
-              <a:t>Subtítulos y música (opcional)</a:t>
-            </a:r>
-          </a:p>
-        </p:txBody>
-      </p:sp>
-      <p:sp>
-        <p:nvSpPr>
-          <p:cNvPr id="21" name="TextBox 20"/>
-          <p:cNvSpPr txBox="1"/>
-          <p:nvPr/>
-        </p:nvSpPr>
-        <p:spPr>
-          <a:xfrm>
-            <a:off x="5394960" y="4937760"/>
-            <a:ext cx="6035040" cy="566928"/>
-          </a:xfrm>
-          <a:prstGeom prst="rect">
-            <a:avLst/>
-          </a:prstGeom>
-          <a:noFill/>
-        </p:spPr>
-        <p:txBody>
-          <a:bodyPr wrap="square" lIns="0" rIns="0" tIns="0" bIns="0">
-            <a:spAutoFit/>
-          </a:bodyPr>
-          <a:lstStyle/>
-          <a:p>
-            <a:pPr algn="l">
-              <a:lnSpc>
-                <a:spcPct val="112000"/>
-              </a:lnSpc>
-              <a:spcAft>
-                <a:spcPts val="0"/>
-              </a:spcAft>
-            </a:pPr>
-            <a:r>
-              <a:rPr sz="1700" b="0">
-                <a:solidFill>
-                  <a:srgbClr val="6E6E6E"/>
-                </a:solidFill>
-                <a:latin typeface="Helvetica Neue"/>
-              </a:rPr>
               <a:t>CapCut</a:t>
             </a:r>
           </a:p>
@@ -12696,7 +12548,7 @@
       </p:sp>
       <p:sp>
         <p:nvSpPr>
-          <p:cNvPr id="22" name="Rounded Rectangle 21"/>
+          <p:cNvPr id="19" name="Rounded Rectangle 18"/>
           <p:cNvSpPr/>
           <p:nvPr/>
         </p:nvSpPr>
@@ -12742,7 +12594,7 @@
       </p:sp>
       <p:sp>
         <p:nvSpPr>
-          <p:cNvPr id="23" name="TextBox 22"/>
+          <p:cNvPr id="20" name="TextBox 19"/>
           <p:cNvSpPr txBox="1"/>
           <p:nvPr/>
         </p:nvSpPr>
@@ -12777,7 +12629,7 @@
                 </a:solidFill>
                 <a:latin typeface="Helvetica Neue"/>
               </a:rPr>
-              <a:t>La puerta gratuita es Google Flow: 50 créditos al día, 15 por clip.</a:t>
+              <a:t>Flow: 50 créditos al día, 10 por clip. Cuatro clips y uno de repuesto.</a:t>
             </a:r>
           </a:p>
           <a:p>
@@ -12796,7 +12648,7 @@
                 </a:solidFill>
                 <a:latin typeface="Helvetica Neue"/>
               </a:rPr>
-              <a:t>Te alcanza para tres clips. Ni uno de sobra: el guion tiene que estar listo antes.</a:t>
+              <a:t>Crear el personaje no gasta nada. La cuenta de la Universidad no sirve.</a:t>
             </a:r>
           </a:p>
         </p:txBody>
@@ -13530,7 +13382,7 @@
                 </a:solidFill>
                 <a:latin typeface="Helvetica Neue"/>
               </a:rPr>
-              <a:t>Y enseguida, partirlo en tres</a:t>
+              <a:t>Y enseguida, partirlo en cuatro</a:t>
             </a:r>
           </a:p>
         </p:txBody>
@@ -13639,7 +13491,7 @@
                 </a:solidFill>
                 <a:latin typeface="Helvetica Neue"/>
               </a:rPr>
-              <a:t>3 clips × 10 segundos  =  75 palabras</a:t>
+              <a:t>4 clips × 8 segundos  =  80 palabras</a:t>
             </a:r>
           </a:p>
           <a:p>
@@ -14265,7 +14117,7 @@
                 </a:solidFill>
                 <a:latin typeface="Helvetica Neue"/>
               </a:rPr>
-              <a:t>Después lo pules: «Limpia este dictado, quita las muletillas y déjalo en 75 palabras».</a:t>
+              <a:t>Después lo pules: «Limpia este dictado, quita las muletillas y déjalo en 80 palabras».</a:t>
             </a:r>
           </a:p>
         </p:txBody>
@@ -14413,7 +14265,7 @@
                 </a:solidFill>
                 <a:latin typeface="Helvetica Neue"/>
               </a:rPr>
-              <a:t>Tu foto</a:t>
+              <a:t>Tu personaje</a:t>
             </a:r>
           </a:p>
         </p:txBody>
@@ -14452,7 +14304,7 @@
                 </a:solidFill>
                 <a:latin typeface="Helvetica Neue"/>
               </a:rPr>
-              <a:t>La misma en los tres clips</a:t>
+              <a:t>Se crea una vez, no gasta créditos, y lleva voz propia</a:t>
             </a:r>
           </a:p>
         </p:txBody>
@@ -14542,7 +14394,7 @@
                 </a:solidFill>
                 <a:latin typeface="Helvetica Neue"/>
               </a:rPr>
-              <a:t>Qué sirve</a:t>
+              <a:t>Con tu foto</a:t>
             </a:r>
           </a:p>
           <a:p>
@@ -14571,7 +14423,7 @@
                 </a:solidFill>
                 <a:latin typeface="Helvetica Neue"/>
               </a:rPr>
-              <a:t>De frente, cara bien iluminada, sin gafas de sol, sin otras personas.</a:t>
+              <a:t>Botón Subir y eliges una foto tuya de frente, bien iluminada.</a:t>
             </a:r>
           </a:p>
         </p:txBody>
@@ -14661,7 +14513,7 @@
                 </a:solidFill>
                 <a:latin typeface="Helvetica Neue"/>
               </a:rPr>
-              <a:t>Sin tu cara</a:t>
+              <a:t>Descrito</a:t>
             </a:r>
           </a:p>
           <a:p>
@@ -14690,7 +14542,7 @@
                 </a:solidFill>
                 <a:latin typeface="Helvetica Neue"/>
               </a:rPr>
-              <a:t>No adjuntes nada y describe un personaje. La misma descripción en los tres.</a:t>
+              <a:t>Escribes cómo es y Flow lo dibuja. Queda igual de consistente.</a:t>
             </a:r>
           </a:p>
         </p:txBody>
@@ -14704,7 +14556,7 @@
         <p:spPr>
           <a:xfrm>
             <a:off x="2103120" y="5166360"/>
-            <a:ext cx="8778240" cy="914400"/>
+            <a:ext cx="8778240" cy="1234440"/>
           </a:xfrm>
           <a:prstGeom prst="roundRect">
             <a:avLst>
@@ -14749,8 +14601,8 @@
         </p:nvSpPr>
         <p:spPr>
           <a:xfrm>
-            <a:off x="2560320" y="5413248"/>
-            <a:ext cx="8046720" cy="548640"/>
+            <a:off x="2560320" y="5394960"/>
+            <a:ext cx="8046720" cy="914400"/>
           </a:xfrm>
           <a:prstGeom prst="rect">
             <a:avLst/>
@@ -14764,8 +14616,11 @@
           <a:lstStyle/>
           <a:p>
             <a:pPr algn="l">
-              <a:spcAft>
-                <a:spcPts val="600"/>
+              <a:lnSpc>
+                <a:spcPct val="130000"/>
+              </a:lnSpc>
+              <a:spcAft>
+                <a:spcPts val="200"/>
               </a:spcAft>
             </a:pPr>
             <a:r>
@@ -14775,7 +14630,26 @@
                 </a:solidFill>
                 <a:latin typeface="Helvetica Neue"/>
               </a:rPr>
-              <a:t>Si cambias de foto entre clips, cambias de persona.</a:t>
+              <a:t>Asígnale una voz antes de generar nada: así suena igual en los cuatro clips.</a:t>
+            </a:r>
+          </a:p>
+          <a:p>
+            <a:pPr algn="l">
+              <a:lnSpc>
+                <a:spcPct val="130000"/>
+              </a:lnSpc>
+              <a:spcAft>
+                <a:spcPts val="200"/>
+              </a:spcAft>
+            </a:pPr>
+            <a:r>
+              <a:rPr sz="1500" b="0">
+                <a:solidFill>
+                  <a:srgbClr val="6E6E6E"/>
+                </a:solidFill>
+                <a:latin typeface="Helvetica Neue"/>
+              </a:rPr>
+              <a:t>Y créalo en el lugar del video: el personaje se trae consigo su escenario.</a:t>
             </a:r>
           </a:p>
         </p:txBody>
@@ -14962,7 +14836,7 @@
                 </a:solidFill>
                 <a:latin typeface="Helvetica Neue"/>
               </a:rPr>
-              <a:t>Tres, uno por frase. Diez segundos cada uno, con voz incluida</a:t>
+              <a:t>Cuatro, uno por frase. Ocho segundos cada uno, con voz</a:t>
             </a:r>
           </a:p>
         </p:txBody>
@@ -15048,11 +14922,11 @@
             <a:r>
               <a:rPr sz="1900" b="1">
                 <a:solidFill>
-                  <a:srgbClr val="ED7623"/>
-                </a:solidFill>
-                <a:latin typeface="Helvetica Neue"/>
-              </a:rPr>
-              <a:t>Google Flow — 50 créditos al día, 15 por clip</a:t>
+                  <a:srgbClr val="11406E"/>
+                </a:solidFill>
+                <a:latin typeface="Helvetica Neue"/>
+              </a:rPr>
+              <a:t>Botón +  →  eliges tu personaje  →  Agregar a la instrucción</a:t>
             </a:r>
           </a:p>
           <a:p>
@@ -15064,15 +14938,6 @@
                 <a:spcPts val="400"/>
               </a:spcAft>
             </a:pPr>
-            <a:r>
-              <a:rPr sz="1900" b="1">
-                <a:solidFill>
-                  <a:srgbClr val="35789C"/>
-                </a:solidFill>
-                <a:latin typeface="Helvetica Neue"/>
-              </a:rPr>
-              <a:t>Pídele «usa omni» o te dará solo 8 segundos</a:t>
-            </a:r>
           </a:p>
           <a:p>
             <a:pPr algn="l">
@@ -15083,16 +14948,6 @@
                 <a:spcPts val="400"/>
               </a:spcAft>
             </a:pPr>
-          </a:p>
-          <a:p>
-            <a:pPr algn="l">
-              <a:lnSpc>
-                <a:spcPct val="135000"/>
-              </a:lnSpc>
-              <a:spcAft>
-                <a:spcPts val="400"/>
-              </a:spcAft>
-            </a:pPr>
             <a:r>
               <a:rPr sz="1500" b="0">
                 <a:solidFill>
@@ -15100,7 +14955,7 @@
                 </a:solidFill>
                 <a:latin typeface="Helvetica Neue"/>
               </a:rPr>
-              <a:t>Dos a cuatro minutos por clip. Lánzalos seguidos. El prompt está en las notas.</a:t>
+              <a:t>10 créditos por clip. Cuatro clips, y te queda uno de repuesto.</a:t>
             </a:r>
           </a:p>
         </p:txBody>
@@ -15188,7 +15043,7 @@
                 </a:solidFill>
                 <a:latin typeface="Helvetica Neue"/>
               </a:rPr>
-              <a:t>En la app de Gemini: primero Crear video, después la foto.</a:t>
+              <a:t>Adjunta el personaje, no lo menciones por escrito.</a:t>
             </a:r>
           </a:p>
           <a:p>
@@ -15207,7 +15062,7 @@
                 </a:solidFill>
                 <a:latin typeface="Helvetica Neue"/>
               </a:rPr>
-              <a:t>Al revés se sale del modo video y te contesta por escrito.</a:t>
+              <a:t>Si solo lo mencionas, Flow genera otra persona distinta.</a:t>
             </a:r>
           </a:p>
           <a:p>
@@ -15226,7 +15081,7 @@
                 </a:solidFill>
                 <a:latin typeface="Helvetica Neue"/>
               </a:rPr>
-              <a:t>Antes de enviar, comprueba que abajo diga «Videos».</a:t>
+              <a:t>Debe responderte que usa «la entidad del personaje referenciada».</a:t>
             </a:r>
           </a:p>
         </p:txBody>

</xml_diff>